<commit_message>
split security into two
</commit_message>
<xml_diff>
--- a/Everyone/THE_FinalPiParty.pptx
+++ b/Everyone/THE_FinalPiParty.pptx
@@ -5,7 +5,7 @@
     <p:sldMasterId id="2147483648" r:id="rId1"/>
   </p:sldMasterIdLst>
   <p:notesMasterIdLst>
-    <p:notesMasterId r:id="rId13"/>
+    <p:notesMasterId r:id="rId14"/>
   </p:notesMasterIdLst>
   <p:sldIdLst>
     <p:sldId id="256" r:id="rId4"/>
@@ -17,6 +17,7 @@
     <p:sldId id="262" r:id="rId10"/>
     <p:sldId id="263" r:id="rId11"/>
     <p:sldId id="264" r:id="rId12"/>
+    <p:sldId id="265" r:id="rId13"/>
   </p:sldIdLst>
   <p:sldSz cx="12192000" cy="6858000"/>
   <p:notesSz cx="6858000" cy="9144000"/>
@@ -42,7 +43,7 @@
       </p:grpSpPr>
       <p:sp>
         <p:nvSpPr>
-          <p:cNvPr id="1780383368" name="PlaceHolder 1"/>
+          <p:cNvPr id="1646903249" name="PlaceHolder 1"/>
           <p:cNvSpPr>
             <a:spLocks noGrp="1"/>
           </p:cNvSpPr>
@@ -94,7 +95,7 @@
       </p:sp>
       <p:sp>
         <p:nvSpPr>
-          <p:cNvPr id="443945608" name="PlaceHolder 2"/>
+          <p:cNvPr id="132676276" name="PlaceHolder 2"/>
           <p:cNvSpPr>
             <a:spLocks noGrp="1"/>
           </p:cNvSpPr>
@@ -144,7 +145,7 @@
       </p:sp>
       <p:sp>
         <p:nvSpPr>
-          <p:cNvPr id="1249242403" name="PlaceHolder 3"/>
+          <p:cNvPr id="1342987194" name="PlaceHolder 3"/>
           <p:cNvSpPr>
             <a:spLocks noGrp="1"/>
           </p:cNvSpPr>
@@ -194,7 +195,7 @@
       </p:sp>
       <p:sp>
         <p:nvSpPr>
-          <p:cNvPr id="1007559506" name="PlaceHolder 4"/>
+          <p:cNvPr id="756919487" name="PlaceHolder 4"/>
           <p:cNvSpPr>
             <a:spLocks noGrp="1"/>
           </p:cNvSpPr>
@@ -255,7 +256,7 @@
       </p:sp>
       <p:sp>
         <p:nvSpPr>
-          <p:cNvPr id="508161485" name="PlaceHolder 5"/>
+          <p:cNvPr id="1056574810" name="PlaceHolder 5"/>
           <p:cNvSpPr>
             <a:spLocks noGrp="1"/>
           </p:cNvSpPr>
@@ -316,7 +317,7 @@
       </p:sp>
       <p:sp>
         <p:nvSpPr>
-          <p:cNvPr id="171734616" name="PlaceHolder 6"/>
+          <p:cNvPr id="1683722565" name="PlaceHolder 6"/>
           <p:cNvSpPr>
             <a:spLocks noGrp="1"/>
           </p:cNvSpPr>
@@ -400,7 +401,7 @@
       </p:grpSpPr>
       <p:sp>
         <p:nvSpPr>
-          <p:cNvPr id="700820022" name="PlaceHolder 1"/>
+          <p:cNvPr id="1657682679" name="PlaceHolder 1"/>
           <p:cNvSpPr>
             <a:spLocks noGrp="1"/>
           </p:cNvSpPr>
@@ -423,7 +424,7 @@
       </p:sp>
       <p:sp>
         <p:nvSpPr>
-          <p:cNvPr id="618866223" name="PlaceHolder 2"/>
+          <p:cNvPr id="1321701883" name="PlaceHolder 2"/>
           <p:cNvSpPr>
             <a:spLocks noGrp="1"/>
           </p:cNvSpPr>
@@ -464,12 +465,142 @@
       </p:sp>
       <p:sp>
         <p:nvSpPr>
-          <p:cNvPr id="1391601071" name="PlaceHolder 3"/>
+          <p:cNvPr id="889762964" name="PlaceHolder 3"/>
           <p:cNvSpPr>
             <a:spLocks noGrp="1"/>
           </p:cNvSpPr>
           <p:nvPr>
             <p:ph type="sldNum" idx="55"/>
+          </p:nvPr>
+        </p:nvSpPr>
+        <p:spPr bwMode="auto">
+          <a:xfrm>
+            <a:off x="3884760" y="8685360"/>
+            <a:ext cx="2971080" cy="457920"/>
+          </a:xfrm>
+          <a:prstGeom prst="rect">
+            <a:avLst/>
+          </a:prstGeom>
+          <a:noFill/>
+          <a:ln w="0">
+            <a:noFill/>
+          </a:ln>
+        </p:spPr>
+        <p:txBody>
+          <a:bodyPr lIns="91440" tIns="45720" rIns="91440" bIns="45720" anchor="b">
+            <a:noAutofit/>
+          </a:bodyPr>
+          <a:p>
+            <a:pPr indent="0" algn="l">
+              <a:buNone/>
+              <a:defRPr/>
+            </a:pPr>
+            <a:endParaRPr lang="en-US" sz="1400" b="0" u="none" strike="noStrike">
+              <a:solidFill>
+                <a:srgbClr val="000000"/>
+              </a:solidFill>
+              <a:latin typeface="Times New Roman"/>
+            </a:endParaRPr>
+          </a:p>
+        </p:txBody>
+      </p:sp>
+    </p:spTree>
+  </p:cSld>
+  <p:clrMapOvr>
+    <a:masterClrMapping/>
+  </p:clrMapOvr>
+</p:notes>
+</file>
+
+<file path=ppt/notesSlides/notesSlide10.xml><?xml version="1.0" encoding="utf-8"?>
+<p:notes xmlns:a="http://schemas.openxmlformats.org/drawingml/2006/main" xmlns:r="http://schemas.openxmlformats.org/officeDocument/2006/relationships" xmlns:p="http://schemas.openxmlformats.org/presentationml/2006/main" xmlns:m="http://schemas.openxmlformats.org/officeDocument/2006/math" xmlns:w="http://schemas.openxmlformats.org/wordprocessingml/2006/main">
+  <p:cSld name="">
+    <p:spTree>
+      <p:nvGrpSpPr>
+        <p:cNvPr id="1" name=""/>
+        <p:cNvGrpSpPr/>
+        <p:nvPr/>
+      </p:nvGrpSpPr>
+      <p:grpSpPr bwMode="auto">
+        <a:xfrm>
+          <a:off x="0" y="0"/>
+          <a:ext cx="0" cy="0"/>
+          <a:chOff x="0" y="0"/>
+          <a:chExt cx="0" cy="0"/>
+        </a:xfrm>
+      </p:grpSpPr>
+      <p:sp>
+        <p:nvSpPr>
+          <p:cNvPr id="377511873" name="PlaceHolder 1"/>
+          <p:cNvSpPr>
+            <a:spLocks noGrp="1"/>
+          </p:cNvSpPr>
+          <p:nvPr>
+            <p:ph type="sldImg"/>
+          </p:nvPr>
+        </p:nvSpPr>
+        <p:spPr bwMode="auto">
+          <a:xfrm>
+            <a:off x="0" y="0"/>
+            <a:ext cx="0" cy="0"/>
+          </a:xfrm>
+          <a:prstGeom prst="rect">
+            <a:avLst/>
+          </a:prstGeom>
+          <a:ln w="0">
+            <a:noFill/>
+          </a:ln>
+        </p:spPr>
+      </p:sp>
+      <p:sp>
+        <p:nvSpPr>
+          <p:cNvPr id="1227661249" name="PlaceHolder 2"/>
+          <p:cNvSpPr>
+            <a:spLocks noGrp="1"/>
+          </p:cNvSpPr>
+          <p:nvPr>
+            <p:ph type="body"/>
+          </p:nvPr>
+        </p:nvSpPr>
+        <p:spPr bwMode="auto">
+          <a:xfrm>
+            <a:off x="685800" y="4400640"/>
+            <a:ext cx="5485680" cy="3599640"/>
+          </a:xfrm>
+          <a:prstGeom prst="rect">
+            <a:avLst/>
+          </a:prstGeom>
+          <a:noFill/>
+          <a:ln w="0">
+            <a:noFill/>
+          </a:ln>
+        </p:spPr>
+        <p:txBody>
+          <a:bodyPr lIns="91440" tIns="45720" rIns="91440" bIns="45720" anchor="ctr">
+            <a:noAutofit/>
+          </a:bodyPr>
+          <a:p>
+            <a:pPr indent="0" algn="l">
+              <a:buNone/>
+              <a:defRPr/>
+            </a:pPr>
+            <a:endParaRPr lang="en-US" sz="1800" b="0" u="none" strike="noStrike">
+              <a:solidFill>
+                <a:srgbClr val="000000"/>
+              </a:solidFill>
+              <a:latin typeface="Arial"/>
+            </a:endParaRPr>
+          </a:p>
+        </p:txBody>
+      </p:sp>
+      <p:sp>
+        <p:nvSpPr>
+          <p:cNvPr id="514680472" name="PlaceHolder 3"/>
+          <p:cNvSpPr>
+            <a:spLocks noGrp="1"/>
+          </p:cNvSpPr>
+          <p:nvPr>
+            <p:ph type="sldNum" idx="62"/>
           </p:nvPr>
         </p:nvSpPr>
         <p:spPr bwMode="auto">
@@ -530,7 +661,7 @@
       </p:grpSpPr>
       <p:sp>
         <p:nvSpPr>
-          <p:cNvPr id="613121280" name="PlaceHolder 1"/>
+          <p:cNvPr id="2052685738" name="PlaceHolder 1"/>
           <p:cNvSpPr>
             <a:spLocks noGrp="1"/>
           </p:cNvSpPr>
@@ -553,7 +684,7 @@
       </p:sp>
       <p:sp>
         <p:nvSpPr>
-          <p:cNvPr id="256060299" name="PlaceHolder 2"/>
+          <p:cNvPr id="395654856" name="PlaceHolder 2"/>
           <p:cNvSpPr>
             <a:spLocks noGrp="1"/>
           </p:cNvSpPr>
@@ -594,7 +725,7 @@
       </p:sp>
       <p:sp>
         <p:nvSpPr>
-          <p:cNvPr id="296904757" name="PlaceHolder 3"/>
+          <p:cNvPr id="417995923" name="PlaceHolder 3"/>
           <p:cNvSpPr>
             <a:spLocks noGrp="1"/>
           </p:cNvSpPr>
@@ -660,7 +791,7 @@
       </p:grpSpPr>
       <p:sp>
         <p:nvSpPr>
-          <p:cNvPr id="986905205" name="PlaceHolder 1"/>
+          <p:cNvPr id="1730261257" name="PlaceHolder 1"/>
           <p:cNvSpPr>
             <a:spLocks noGrp="1"/>
           </p:cNvSpPr>
@@ -683,7 +814,7 @@
       </p:sp>
       <p:sp>
         <p:nvSpPr>
-          <p:cNvPr id="1128209399" name="PlaceHolder 2"/>
+          <p:cNvPr id="902864142" name="PlaceHolder 2"/>
           <p:cNvSpPr>
             <a:spLocks noGrp="1"/>
           </p:cNvSpPr>
@@ -724,7 +855,7 @@
       </p:sp>
       <p:sp>
         <p:nvSpPr>
-          <p:cNvPr id="1320596344" name="PlaceHolder 3"/>
+          <p:cNvPr id="583441743" name="PlaceHolder 3"/>
           <p:cNvSpPr>
             <a:spLocks noGrp="1"/>
           </p:cNvSpPr>
@@ -790,7 +921,7 @@
       </p:grpSpPr>
       <p:sp>
         <p:nvSpPr>
-          <p:cNvPr id="1755474917" name="PlaceHolder 1"/>
+          <p:cNvPr id="310791863" name="PlaceHolder 1"/>
           <p:cNvSpPr>
             <a:spLocks noGrp="1"/>
           </p:cNvSpPr>
@@ -813,7 +944,7 @@
       </p:sp>
       <p:sp>
         <p:nvSpPr>
-          <p:cNvPr id="1418311009" name="PlaceHolder 2"/>
+          <p:cNvPr id="675312068" name="PlaceHolder 2"/>
           <p:cNvSpPr>
             <a:spLocks noGrp="1"/>
           </p:cNvSpPr>
@@ -854,12 +985,12 @@
       </p:sp>
       <p:sp>
         <p:nvSpPr>
-          <p:cNvPr id="1562151630" name="PlaceHolder 3"/>
+          <p:cNvPr id="1164715620" name="PlaceHolder 3"/>
           <p:cNvSpPr>
             <a:spLocks noGrp="1"/>
           </p:cNvSpPr>
           <p:nvPr>
-            <p:ph type="sldNum" idx="57"/>
+            <p:ph type="sldNum" idx="56"/>
           </p:nvPr>
         </p:nvSpPr>
         <p:spPr bwMode="auto">
@@ -920,7 +1051,7 @@
       </p:grpSpPr>
       <p:sp>
         <p:nvSpPr>
-          <p:cNvPr id="1245705899" name="PlaceHolder 1"/>
+          <p:cNvPr id="630807000" name="PlaceHolder 1"/>
           <p:cNvSpPr>
             <a:spLocks noGrp="1"/>
           </p:cNvSpPr>
@@ -943,7 +1074,7 @@
       </p:sp>
       <p:sp>
         <p:nvSpPr>
-          <p:cNvPr id="835862022" name="PlaceHolder 2"/>
+          <p:cNvPr id="1031216990" name="PlaceHolder 2"/>
           <p:cNvSpPr>
             <a:spLocks noGrp="1"/>
           </p:cNvSpPr>
@@ -984,12 +1115,12 @@
       </p:sp>
       <p:sp>
         <p:nvSpPr>
-          <p:cNvPr id="1828970274" name="PlaceHolder 3"/>
+          <p:cNvPr id="1216431904" name="PlaceHolder 3"/>
           <p:cNvSpPr>
             <a:spLocks noGrp="1"/>
           </p:cNvSpPr>
           <p:nvPr>
-            <p:ph type="sldNum" idx="58"/>
+            <p:ph type="sldNum" idx="57"/>
           </p:nvPr>
         </p:nvSpPr>
         <p:spPr bwMode="auto">
@@ -1050,7 +1181,7 @@
       </p:grpSpPr>
       <p:sp>
         <p:nvSpPr>
-          <p:cNvPr id="701557138" name="PlaceHolder 1"/>
+          <p:cNvPr id="599784622" name="PlaceHolder 1"/>
           <p:cNvSpPr>
             <a:spLocks noGrp="1"/>
           </p:cNvSpPr>
@@ -1073,7 +1204,7 @@
       </p:sp>
       <p:sp>
         <p:nvSpPr>
-          <p:cNvPr id="810562608" name="PlaceHolder 2"/>
+          <p:cNvPr id="548197657" name="PlaceHolder 2"/>
           <p:cNvSpPr>
             <a:spLocks noGrp="1"/>
           </p:cNvSpPr>
@@ -1114,12 +1245,12 @@
       </p:sp>
       <p:sp>
         <p:nvSpPr>
-          <p:cNvPr id="165493891" name="PlaceHolder 3"/>
+          <p:cNvPr id="2068526860" name="PlaceHolder 3"/>
           <p:cNvSpPr>
             <a:spLocks noGrp="1"/>
           </p:cNvSpPr>
           <p:nvPr>
-            <p:ph type="sldNum" idx="59"/>
+            <p:ph type="sldNum" idx="58"/>
           </p:nvPr>
         </p:nvSpPr>
         <p:spPr bwMode="auto">
@@ -1180,7 +1311,7 @@
       </p:grpSpPr>
       <p:sp>
         <p:nvSpPr>
-          <p:cNvPr id="1220965173" name="PlaceHolder 1"/>
+          <p:cNvPr id="1645619026" name="PlaceHolder 1"/>
           <p:cNvSpPr>
             <a:spLocks noGrp="1"/>
           </p:cNvSpPr>
@@ -1203,7 +1334,7 @@
       </p:sp>
       <p:sp>
         <p:nvSpPr>
-          <p:cNvPr id="364143557" name="PlaceHolder 2"/>
+          <p:cNvPr id="1385528772" name="PlaceHolder 2"/>
           <p:cNvSpPr>
             <a:spLocks noGrp="1"/>
           </p:cNvSpPr>
@@ -1244,12 +1375,12 @@
       </p:sp>
       <p:sp>
         <p:nvSpPr>
-          <p:cNvPr id="1518768513" name="PlaceHolder 3"/>
+          <p:cNvPr id="1371739740" name="PlaceHolder 3"/>
           <p:cNvSpPr>
             <a:spLocks noGrp="1"/>
           </p:cNvSpPr>
           <p:nvPr>
-            <p:ph type="sldNum" idx="60"/>
+            <p:ph type="sldNum" idx="59"/>
           </p:nvPr>
         </p:nvSpPr>
         <p:spPr bwMode="auto">
@@ -1310,7 +1441,7 @@
       </p:grpSpPr>
       <p:sp>
         <p:nvSpPr>
-          <p:cNvPr id="1759332517" name="PlaceHolder 1"/>
+          <p:cNvPr id="859465001" name="PlaceHolder 1"/>
           <p:cNvSpPr>
             <a:spLocks noGrp="1"/>
           </p:cNvSpPr>
@@ -1333,7 +1464,7 @@
       </p:sp>
       <p:sp>
         <p:nvSpPr>
-          <p:cNvPr id="1418040671" name="PlaceHolder 2"/>
+          <p:cNvPr id="451654172" name="PlaceHolder 2"/>
           <p:cNvSpPr>
             <a:spLocks noGrp="1"/>
           </p:cNvSpPr>
@@ -1374,12 +1505,12 @@
       </p:sp>
       <p:sp>
         <p:nvSpPr>
-          <p:cNvPr id="1178510701" name="PlaceHolder 3"/>
+          <p:cNvPr id="556213909" name="PlaceHolder 3"/>
           <p:cNvSpPr>
             <a:spLocks noGrp="1"/>
           </p:cNvSpPr>
           <p:nvPr>
-            <p:ph type="sldNum" idx="61"/>
+            <p:ph type="sldNum" idx="60"/>
           </p:nvPr>
         </p:nvSpPr>
         <p:spPr bwMode="auto">
@@ -1440,7 +1571,7 @@
       </p:grpSpPr>
       <p:sp>
         <p:nvSpPr>
-          <p:cNvPr id="1885799557" name="PlaceHolder 1"/>
+          <p:cNvPr id="861797355" name="PlaceHolder 1"/>
           <p:cNvSpPr>
             <a:spLocks noGrp="1"/>
           </p:cNvSpPr>
@@ -1463,7 +1594,7 @@
       </p:sp>
       <p:sp>
         <p:nvSpPr>
-          <p:cNvPr id="1584405627" name="PlaceHolder 2"/>
+          <p:cNvPr id="1027185458" name="PlaceHolder 2"/>
           <p:cNvSpPr>
             <a:spLocks noGrp="1"/>
           </p:cNvSpPr>
@@ -1504,12 +1635,12 @@
       </p:sp>
       <p:sp>
         <p:nvSpPr>
-          <p:cNvPr id="421088439" name="PlaceHolder 3"/>
+          <p:cNvPr id="1671900449" name="PlaceHolder 3"/>
           <p:cNvSpPr>
             <a:spLocks noGrp="1"/>
           </p:cNvSpPr>
           <p:nvPr>
-            <p:ph type="sldNum" idx="62"/>
+            <p:ph type="sldNum" idx="61"/>
           </p:nvPr>
         </p:nvSpPr>
         <p:spPr bwMode="auto">
@@ -1578,7 +1709,7 @@
       </p:grpSpPr>
       <p:pic>
         <p:nvPicPr>
-          <p:cNvPr id="1213326681" name="Picture 6" descr="Celestia-R1---OverlayContentHD.png"/>
+          <p:cNvPr id="1875336729" name="Picture 6" descr="Celestia-R1---OverlayContentHD.png"/>
           <p:cNvPicPr/>
           <p:nvPr/>
         </p:nvPicPr>
@@ -1602,7 +1733,7 @@
       </p:pic>
       <p:sp>
         <p:nvSpPr>
-          <p:cNvPr id="273601709" name="PlaceHolder 1"/>
+          <p:cNvPr id="481846403" name="PlaceHolder 1"/>
           <p:cNvSpPr>
             <a:spLocks noGrp="1"/>
           </p:cNvSpPr>
@@ -1677,7 +1808,7 @@
       </p:sp>
       <p:sp>
         <p:nvSpPr>
-          <p:cNvPr id="466729598" name="PlaceHolder 2"/>
+          <p:cNvPr id="609795059" name="PlaceHolder 2"/>
           <p:cNvSpPr>
             <a:spLocks noGrp="1"/>
           </p:cNvSpPr>
@@ -1968,7 +2099,7 @@
       </p:sp>
       <p:sp>
         <p:nvSpPr>
-          <p:cNvPr id="623279379" name="PlaceHolder 3"/>
+          <p:cNvPr id="1016955062" name="PlaceHolder 3"/>
           <p:cNvSpPr>
             <a:spLocks noGrp="1"/>
           </p:cNvSpPr>
@@ -2043,7 +2174,7 @@
       </p:sp>
       <p:sp>
         <p:nvSpPr>
-          <p:cNvPr id="977503525" name="PlaceHolder 4"/>
+          <p:cNvPr id="1329634577" name="PlaceHolder 4"/>
           <p:cNvSpPr>
             <a:spLocks noGrp="1"/>
           </p:cNvSpPr>
@@ -2116,7 +2247,7 @@
       </p:sp>
       <p:sp>
         <p:nvSpPr>
-          <p:cNvPr id="1532638689" name="PlaceHolder 5"/>
+          <p:cNvPr id="2027452599" name="PlaceHolder 5"/>
           <p:cNvSpPr>
             <a:spLocks noGrp="1"/>
           </p:cNvSpPr>
@@ -2224,7 +2355,7 @@
       </p:grpSpPr>
       <p:pic>
         <p:nvPicPr>
-          <p:cNvPr id="1736386586" name="Picture 6" descr="Celestia-R1---OverlayTitleHD.png"/>
+          <p:cNvPr id="1984119242" name="Picture 6" descr="Celestia-R1---OverlayTitleHD.png"/>
           <p:cNvPicPr/>
           <p:nvPr/>
         </p:nvPicPr>
@@ -2248,7 +2379,7 @@
       </p:pic>
       <p:sp>
         <p:nvSpPr>
-          <p:cNvPr id="121475264" name="PlaceHolder 1"/>
+          <p:cNvPr id="41909088" name="PlaceHolder 1"/>
           <p:cNvSpPr>
             <a:spLocks noGrp="1"/>
           </p:cNvSpPr>
@@ -2323,7 +2454,7 @@
       </p:sp>
       <p:sp>
         <p:nvSpPr>
-          <p:cNvPr id="1004661782" name="PlaceHolder 2"/>
+          <p:cNvPr id="718425191" name="PlaceHolder 2"/>
           <p:cNvSpPr>
             <a:spLocks noGrp="1"/>
           </p:cNvSpPr>
@@ -2398,7 +2529,7 @@
       </p:sp>
       <p:sp>
         <p:nvSpPr>
-          <p:cNvPr id="850553948" name="PlaceHolder 3"/>
+          <p:cNvPr id="1970010722" name="PlaceHolder 3"/>
           <p:cNvSpPr>
             <a:spLocks noGrp="1"/>
           </p:cNvSpPr>
@@ -2471,7 +2602,7 @@
       </p:sp>
       <p:sp>
         <p:nvSpPr>
-          <p:cNvPr id="1941247479" name="PlaceHolder 4"/>
+          <p:cNvPr id="433000330" name="PlaceHolder 4"/>
           <p:cNvSpPr>
             <a:spLocks noGrp="1"/>
           </p:cNvSpPr>
@@ -2546,7 +2677,7 @@
       </p:sp>
       <p:sp>
         <p:nvSpPr>
-          <p:cNvPr id="1545523079" name="PlaceHolder 5"/>
+          <p:cNvPr id="1212171979" name="PlaceHolder 5"/>
           <p:cNvSpPr>
             <a:spLocks noGrp="1"/>
           </p:cNvSpPr>
@@ -2972,7 +3103,7 @@
       </p:grpSpPr>
       <p:pic>
         <p:nvPicPr>
-          <p:cNvPr id="1418609214" name="Picture 7" descr="Celestia-R1---OverlayContentHD.png"/>
+          <p:cNvPr id="1028210237" name="Picture 7" descr="Celestia-R1---OverlayContentHD.png"/>
           <p:cNvPicPr/>
           <p:nvPr/>
         </p:nvPicPr>
@@ -2996,7 +3127,7 @@
       </p:pic>
       <p:sp>
         <p:nvSpPr>
-          <p:cNvPr id="2040951353" name="PlaceHolder 1"/>
+          <p:cNvPr id="1723567047" name="PlaceHolder 1"/>
           <p:cNvSpPr>
             <a:spLocks noGrp="1"/>
           </p:cNvSpPr>
@@ -3071,7 +3202,7 @@
       </p:sp>
       <p:sp>
         <p:nvSpPr>
-          <p:cNvPr id="861825872" name="PlaceHolder 2"/>
+          <p:cNvPr id="1126694619" name="PlaceHolder 2"/>
           <p:cNvSpPr>
             <a:spLocks noGrp="1"/>
           </p:cNvSpPr>
@@ -3156,7 +3287,7 @@
       </p:sp>
       <p:sp>
         <p:nvSpPr>
-          <p:cNvPr id="708601621" name="PlaceHolder 3"/>
+          <p:cNvPr id="385499855" name="PlaceHolder 3"/>
           <p:cNvSpPr>
             <a:spLocks noGrp="1"/>
           </p:cNvSpPr>
@@ -3237,7 +3368,7 @@
       </p:sp>
       <p:sp>
         <p:nvSpPr>
-          <p:cNvPr id="1209226495" name="PlaceHolder 4"/>
+          <p:cNvPr id="27642929" name="PlaceHolder 4"/>
           <p:cNvSpPr>
             <a:spLocks noGrp="1"/>
           </p:cNvSpPr>
@@ -3312,7 +3443,7 @@
       </p:sp>
       <p:sp>
         <p:nvSpPr>
-          <p:cNvPr id="2078238445" name="PlaceHolder 5"/>
+          <p:cNvPr id="793599931" name="PlaceHolder 5"/>
           <p:cNvSpPr>
             <a:spLocks noGrp="1"/>
           </p:cNvSpPr>
@@ -3385,7 +3516,7 @@
       </p:sp>
       <p:sp>
         <p:nvSpPr>
-          <p:cNvPr id="391875119" name="PlaceHolder 6"/>
+          <p:cNvPr id="302423544" name="PlaceHolder 6"/>
           <p:cNvSpPr>
             <a:spLocks noGrp="1"/>
           </p:cNvSpPr>
@@ -3493,7 +3624,7 @@
       </p:grpSpPr>
       <p:pic>
         <p:nvPicPr>
-          <p:cNvPr id="253602861" name="Picture 6" descr="Celestia-R1---OverlayContentHD.png"/>
+          <p:cNvPr id="996293249" name="Picture 6" descr="Celestia-R1---OverlayContentHD.png"/>
           <p:cNvPicPr/>
           <p:nvPr/>
         </p:nvPicPr>
@@ -3517,7 +3648,7 @@
       </p:pic>
       <p:sp>
         <p:nvSpPr>
-          <p:cNvPr id="2051398736" name="PlaceHolder 1"/>
+          <p:cNvPr id="1176607909" name="PlaceHolder 1"/>
           <p:cNvSpPr>
             <a:spLocks noGrp="1"/>
           </p:cNvSpPr>
@@ -3592,7 +3723,7 @@
       </p:sp>
       <p:sp>
         <p:nvSpPr>
-          <p:cNvPr id="131388323" name="PlaceHolder 2"/>
+          <p:cNvPr id="366809604" name="PlaceHolder 2"/>
           <p:cNvSpPr>
             <a:spLocks noGrp="1"/>
           </p:cNvSpPr>
@@ -3673,7 +3804,7 @@
       </p:sp>
       <p:sp>
         <p:nvSpPr>
-          <p:cNvPr id="791888867" name="PlaceHolder 3"/>
+          <p:cNvPr id="1750150730" name="PlaceHolder 3"/>
           <p:cNvSpPr>
             <a:spLocks noGrp="1"/>
           </p:cNvSpPr>
@@ -3748,7 +3879,7 @@
       </p:sp>
       <p:sp>
         <p:nvSpPr>
-          <p:cNvPr id="371064045" name="PlaceHolder 4"/>
+          <p:cNvPr id="353087413" name="PlaceHolder 4"/>
           <p:cNvSpPr>
             <a:spLocks noGrp="1"/>
           </p:cNvSpPr>
@@ -3821,7 +3952,7 @@
       </p:sp>
       <p:sp>
         <p:nvSpPr>
-          <p:cNvPr id="1159607983" name="PlaceHolder 5"/>
+          <p:cNvPr id="104590736" name="PlaceHolder 5"/>
           <p:cNvSpPr>
             <a:spLocks noGrp="1"/>
           </p:cNvSpPr>
@@ -3929,7 +4060,7 @@
       </p:grpSpPr>
       <p:pic>
         <p:nvPicPr>
-          <p:cNvPr id="2090397113" name="Picture 10" descr="Celestia-R1---OverlayContentHD.png"/>
+          <p:cNvPr id="19050425" name="Picture 10" descr="Celestia-R1---OverlayContentHD.png"/>
           <p:cNvPicPr/>
           <p:nvPr/>
         </p:nvPicPr>
@@ -3953,7 +4084,7 @@
       </p:pic>
       <p:sp>
         <p:nvSpPr>
-          <p:cNvPr id="1880619567" name="TextBox 11"/>
+          <p:cNvPr id="627097779" name="TextBox 11"/>
           <p:cNvSpPr/>
           <p:nvPr/>
         </p:nvSpPr>
@@ -4008,7 +4139,7 @@
       </p:sp>
       <p:sp>
         <p:nvSpPr>
-          <p:cNvPr id="273991991" name="TextBox 12"/>
+          <p:cNvPr id="1635361577" name="TextBox 12"/>
           <p:cNvSpPr/>
           <p:nvPr/>
         </p:nvSpPr>
@@ -4063,7 +4194,7 @@
       </p:sp>
       <p:sp>
         <p:nvSpPr>
-          <p:cNvPr id="1498105110" name="PlaceHolder 1"/>
+          <p:cNvPr id="1598088346" name="PlaceHolder 1"/>
           <p:cNvSpPr>
             <a:spLocks noGrp="1"/>
           </p:cNvSpPr>
@@ -4138,7 +4269,7 @@
       </p:sp>
       <p:sp>
         <p:nvSpPr>
-          <p:cNvPr id="917753242" name="PlaceHolder 2"/>
+          <p:cNvPr id="1757162763" name="PlaceHolder 2"/>
           <p:cNvSpPr>
             <a:spLocks noGrp="1"/>
           </p:cNvSpPr>
@@ -4219,7 +4350,7 @@
       </p:sp>
       <p:sp>
         <p:nvSpPr>
-          <p:cNvPr id="2073143600" name="PlaceHolder 3"/>
+          <p:cNvPr id="644562265" name="PlaceHolder 3"/>
           <p:cNvSpPr>
             <a:spLocks noGrp="1"/>
           </p:cNvSpPr>
@@ -4300,7 +4431,7 @@
       </p:sp>
       <p:sp>
         <p:nvSpPr>
-          <p:cNvPr id="232049045" name="PlaceHolder 4"/>
+          <p:cNvPr id="547109103" name="PlaceHolder 4"/>
           <p:cNvSpPr>
             <a:spLocks noGrp="1"/>
           </p:cNvSpPr>
@@ -4375,7 +4506,7 @@
       </p:sp>
       <p:sp>
         <p:nvSpPr>
-          <p:cNvPr id="29986908" name="PlaceHolder 5"/>
+          <p:cNvPr id="209112166" name="PlaceHolder 5"/>
           <p:cNvSpPr>
             <a:spLocks noGrp="1"/>
           </p:cNvSpPr>
@@ -4448,7 +4579,7 @@
       </p:sp>
       <p:sp>
         <p:nvSpPr>
-          <p:cNvPr id="433995738" name="PlaceHolder 6"/>
+          <p:cNvPr id="1820298287" name="PlaceHolder 6"/>
           <p:cNvSpPr>
             <a:spLocks noGrp="1"/>
           </p:cNvSpPr>
@@ -4556,7 +4687,7 @@
       </p:grpSpPr>
       <p:pic>
         <p:nvPicPr>
-          <p:cNvPr id="1432748259" name="Picture 6" descr="Celestia-R1---OverlayContentHD.png"/>
+          <p:cNvPr id="746884893" name="Picture 6" descr="Celestia-R1---OverlayContentHD.png"/>
           <p:cNvPicPr/>
           <p:nvPr/>
         </p:nvPicPr>
@@ -4580,7 +4711,7 @@
       </p:pic>
       <p:sp>
         <p:nvSpPr>
-          <p:cNvPr id="2050484589" name="PlaceHolder 1"/>
+          <p:cNvPr id="88594027" name="PlaceHolder 1"/>
           <p:cNvSpPr>
             <a:spLocks noGrp="1"/>
           </p:cNvSpPr>
@@ -4655,7 +4786,7 @@
       </p:sp>
       <p:sp>
         <p:nvSpPr>
-          <p:cNvPr id="1183934767" name="PlaceHolder 2"/>
+          <p:cNvPr id="980350132" name="PlaceHolder 2"/>
           <p:cNvSpPr>
             <a:spLocks noGrp="1"/>
           </p:cNvSpPr>
@@ -4736,7 +4867,7 @@
       </p:sp>
       <p:sp>
         <p:nvSpPr>
-          <p:cNvPr id="280530914" name="PlaceHolder 3"/>
+          <p:cNvPr id="857060990" name="PlaceHolder 3"/>
           <p:cNvSpPr>
             <a:spLocks noGrp="1"/>
           </p:cNvSpPr>
@@ -4811,7 +4942,7 @@
       </p:sp>
       <p:sp>
         <p:nvSpPr>
-          <p:cNvPr id="176204529" name="PlaceHolder 4"/>
+          <p:cNvPr id="824610807" name="PlaceHolder 4"/>
           <p:cNvSpPr>
             <a:spLocks noGrp="1"/>
           </p:cNvSpPr>
@@ -4884,7 +5015,7 @@
       </p:sp>
       <p:sp>
         <p:nvSpPr>
-          <p:cNvPr id="1509600445" name="PlaceHolder 5"/>
+          <p:cNvPr id="1915743214" name="PlaceHolder 5"/>
           <p:cNvSpPr>
             <a:spLocks noGrp="1"/>
           </p:cNvSpPr>
@@ -4992,7 +5123,7 @@
       </p:grpSpPr>
       <p:pic>
         <p:nvPicPr>
-          <p:cNvPr id="1827783110" name="Picture 10" descr="Celestia-R1---OverlayContentHD.png"/>
+          <p:cNvPr id="1552397754" name="Picture 10" descr="Celestia-R1---OverlayContentHD.png"/>
           <p:cNvPicPr/>
           <p:nvPr/>
         </p:nvPicPr>
@@ -5016,7 +5147,7 @@
       </p:pic>
       <p:sp>
         <p:nvSpPr>
-          <p:cNvPr id="1911174922" name="TextBox 12"/>
+          <p:cNvPr id="791751805" name="TextBox 12"/>
           <p:cNvSpPr/>
           <p:nvPr/>
         </p:nvSpPr>
@@ -5071,7 +5202,7 @@
       </p:sp>
       <p:sp>
         <p:nvSpPr>
-          <p:cNvPr id="2121741851" name="TextBox 13"/>
+          <p:cNvPr id="9243813" name="TextBox 13"/>
           <p:cNvSpPr/>
           <p:nvPr/>
         </p:nvSpPr>
@@ -5126,7 +5257,7 @@
       </p:sp>
       <p:sp>
         <p:nvSpPr>
-          <p:cNvPr id="1961842697" name="PlaceHolder 1"/>
+          <p:cNvPr id="568603506" name="PlaceHolder 1"/>
           <p:cNvSpPr>
             <a:spLocks noGrp="1"/>
           </p:cNvSpPr>
@@ -5201,7 +5332,7 @@
       </p:sp>
       <p:sp>
         <p:nvSpPr>
-          <p:cNvPr id="638605909" name="PlaceHolder 2"/>
+          <p:cNvPr id="1983555191" name="PlaceHolder 2"/>
           <p:cNvSpPr>
             <a:spLocks noGrp="1"/>
           </p:cNvSpPr>
@@ -5282,7 +5413,7 @@
       </p:sp>
       <p:sp>
         <p:nvSpPr>
-          <p:cNvPr id="1870141962" name="PlaceHolder 3"/>
+          <p:cNvPr id="1370506048" name="PlaceHolder 3"/>
           <p:cNvSpPr>
             <a:spLocks noGrp="1"/>
           </p:cNvSpPr>
@@ -5363,7 +5494,7 @@
       </p:sp>
       <p:sp>
         <p:nvSpPr>
-          <p:cNvPr id="184960165" name="PlaceHolder 4"/>
+          <p:cNvPr id="654463351" name="PlaceHolder 4"/>
           <p:cNvSpPr>
             <a:spLocks noGrp="1"/>
           </p:cNvSpPr>
@@ -5438,7 +5569,7 @@
       </p:sp>
       <p:sp>
         <p:nvSpPr>
-          <p:cNvPr id="189898989" name="PlaceHolder 5"/>
+          <p:cNvPr id="2117727146" name="PlaceHolder 5"/>
           <p:cNvSpPr>
             <a:spLocks noGrp="1"/>
           </p:cNvSpPr>
@@ -5511,7 +5642,7 @@
       </p:sp>
       <p:sp>
         <p:nvSpPr>
-          <p:cNvPr id="1911456061" name="PlaceHolder 6"/>
+          <p:cNvPr id="1002938852" name="PlaceHolder 6"/>
           <p:cNvSpPr>
             <a:spLocks noGrp="1"/>
           </p:cNvSpPr>
@@ -5619,7 +5750,7 @@
       </p:grpSpPr>
       <p:pic>
         <p:nvPicPr>
-          <p:cNvPr id="1685155373" name="Picture 7" descr="Celestia-R1---OverlayContentHD.png"/>
+          <p:cNvPr id="1702547001" name="Picture 7" descr="Celestia-R1---OverlayContentHD.png"/>
           <p:cNvPicPr/>
           <p:nvPr/>
         </p:nvPicPr>
@@ -5643,7 +5774,7 @@
       </p:pic>
       <p:sp>
         <p:nvSpPr>
-          <p:cNvPr id="469097945" name="PlaceHolder 1"/>
+          <p:cNvPr id="855649233" name="PlaceHolder 1"/>
           <p:cNvSpPr>
             <a:spLocks noGrp="1"/>
           </p:cNvSpPr>
@@ -5718,7 +5849,7 @@
       </p:sp>
       <p:sp>
         <p:nvSpPr>
-          <p:cNvPr id="956420228" name="PlaceHolder 2"/>
+          <p:cNvPr id="335071856" name="PlaceHolder 2"/>
           <p:cNvSpPr>
             <a:spLocks noGrp="1"/>
           </p:cNvSpPr>
@@ -5799,7 +5930,7 @@
       </p:sp>
       <p:sp>
         <p:nvSpPr>
-          <p:cNvPr id="485692833" name="PlaceHolder 3"/>
+          <p:cNvPr id="712896717" name="PlaceHolder 3"/>
           <p:cNvSpPr>
             <a:spLocks noGrp="1"/>
           </p:cNvSpPr>
@@ -5880,7 +6011,7 @@
       </p:sp>
       <p:sp>
         <p:nvSpPr>
-          <p:cNvPr id="1464396216" name="PlaceHolder 4"/>
+          <p:cNvPr id="711185086" name="PlaceHolder 4"/>
           <p:cNvSpPr>
             <a:spLocks noGrp="1"/>
           </p:cNvSpPr>
@@ -5955,7 +6086,7 @@
       </p:sp>
       <p:sp>
         <p:nvSpPr>
-          <p:cNvPr id="2105358814" name="PlaceHolder 5"/>
+          <p:cNvPr id="552810325" name="PlaceHolder 5"/>
           <p:cNvSpPr>
             <a:spLocks noGrp="1"/>
           </p:cNvSpPr>
@@ -6028,7 +6159,7 @@
       </p:sp>
       <p:sp>
         <p:nvSpPr>
-          <p:cNvPr id="263044372" name="PlaceHolder 6"/>
+          <p:cNvPr id="1441978986" name="PlaceHolder 6"/>
           <p:cNvSpPr>
             <a:spLocks noGrp="1"/>
           </p:cNvSpPr>
@@ -6136,7 +6267,7 @@
       </p:grpSpPr>
       <p:pic>
         <p:nvPicPr>
-          <p:cNvPr id="1948659339" name="Picture 6" descr="Celestia-R1---OverlayContentHD.png"/>
+          <p:cNvPr id="1882560803" name="Picture 6" descr="Celestia-R1---OverlayContentHD.png"/>
           <p:cNvPicPr/>
           <p:nvPr/>
         </p:nvPicPr>
@@ -6160,7 +6291,7 @@
       </p:pic>
       <p:sp>
         <p:nvSpPr>
-          <p:cNvPr id="245182884" name="PlaceHolder 1"/>
+          <p:cNvPr id="63939423" name="PlaceHolder 1"/>
           <p:cNvSpPr>
             <a:spLocks noGrp="1"/>
           </p:cNvSpPr>
@@ -6235,7 +6366,7 @@
       </p:sp>
       <p:sp>
         <p:nvSpPr>
-          <p:cNvPr id="1209281645" name="PlaceHolder 2"/>
+          <p:cNvPr id="594599532" name="PlaceHolder 2"/>
           <p:cNvSpPr>
             <a:spLocks noGrp="1"/>
           </p:cNvSpPr>
@@ -6526,7 +6657,7 @@
       </p:sp>
       <p:sp>
         <p:nvSpPr>
-          <p:cNvPr id="1900528267" name="PlaceHolder 3"/>
+          <p:cNvPr id="1242212990" name="PlaceHolder 3"/>
           <p:cNvSpPr>
             <a:spLocks noGrp="1"/>
           </p:cNvSpPr>
@@ -6601,7 +6732,7 @@
       </p:sp>
       <p:sp>
         <p:nvSpPr>
-          <p:cNvPr id="1718682037" name="PlaceHolder 4"/>
+          <p:cNvPr id="1084337150" name="PlaceHolder 4"/>
           <p:cNvSpPr>
             <a:spLocks noGrp="1"/>
           </p:cNvSpPr>
@@ -6674,7 +6805,7 @@
       </p:sp>
       <p:sp>
         <p:nvSpPr>
-          <p:cNvPr id="645139941" name="PlaceHolder 5"/>
+          <p:cNvPr id="1338770751" name="PlaceHolder 5"/>
           <p:cNvSpPr>
             <a:spLocks noGrp="1"/>
           </p:cNvSpPr>
@@ -6782,7 +6913,7 @@
       </p:grpSpPr>
       <p:pic>
         <p:nvPicPr>
-          <p:cNvPr id="1508006574" name="Picture 6" descr="Celestia-R1---OverlayContentHD.png"/>
+          <p:cNvPr id="1649770656" name="Picture 6" descr="Celestia-R1---OverlayContentHD.png"/>
           <p:cNvPicPr/>
           <p:nvPr/>
         </p:nvPicPr>
@@ -6806,7 +6937,7 @@
       </p:pic>
       <p:sp>
         <p:nvSpPr>
-          <p:cNvPr id="1621624313" name="PlaceHolder 1"/>
+          <p:cNvPr id="1713684007" name="PlaceHolder 1"/>
           <p:cNvSpPr>
             <a:spLocks noGrp="1"/>
           </p:cNvSpPr>
@@ -6881,7 +7012,7 @@
       </p:sp>
       <p:sp>
         <p:nvSpPr>
-          <p:cNvPr id="1313230940" name="PlaceHolder 2"/>
+          <p:cNvPr id="468419926" name="PlaceHolder 2"/>
           <p:cNvSpPr>
             <a:spLocks noGrp="1"/>
           </p:cNvSpPr>
@@ -7172,7 +7303,7 @@
       </p:sp>
       <p:sp>
         <p:nvSpPr>
-          <p:cNvPr id="889319318" name="PlaceHolder 3"/>
+          <p:cNvPr id="1510804100" name="PlaceHolder 3"/>
           <p:cNvSpPr>
             <a:spLocks noGrp="1"/>
           </p:cNvSpPr>
@@ -7247,7 +7378,7 @@
       </p:sp>
       <p:sp>
         <p:nvSpPr>
-          <p:cNvPr id="784123989" name="PlaceHolder 4"/>
+          <p:cNvPr id="157860537" name="PlaceHolder 4"/>
           <p:cNvSpPr>
             <a:spLocks noGrp="1"/>
           </p:cNvSpPr>
@@ -7320,7 +7451,7 @@
       </p:sp>
       <p:sp>
         <p:nvSpPr>
-          <p:cNvPr id="648725374" name="PlaceHolder 5"/>
+          <p:cNvPr id="2134542632" name="PlaceHolder 5"/>
           <p:cNvSpPr>
             <a:spLocks noGrp="1"/>
           </p:cNvSpPr>
@@ -7428,7 +7559,7 @@
       </p:grpSpPr>
       <p:pic>
         <p:nvPicPr>
-          <p:cNvPr id="1919382745" name="Picture 6" descr="Celestia-R1---OverlayContentHD.png"/>
+          <p:cNvPr id="1035727645" name="Picture 6" descr="Celestia-R1---OverlayContentHD.png"/>
           <p:cNvPicPr/>
           <p:nvPr/>
         </p:nvPicPr>
@@ -7452,7 +7583,7 @@
       </p:pic>
       <p:sp>
         <p:nvSpPr>
-          <p:cNvPr id="1628532566" name="PlaceHolder 1"/>
+          <p:cNvPr id="1933388138" name="PlaceHolder 1"/>
           <p:cNvSpPr>
             <a:spLocks noGrp="1"/>
           </p:cNvSpPr>
@@ -7527,7 +7658,7 @@
       </p:sp>
       <p:sp>
         <p:nvSpPr>
-          <p:cNvPr id="148063152" name="PlaceHolder 2"/>
+          <p:cNvPr id="697426012" name="PlaceHolder 2"/>
           <p:cNvSpPr>
             <a:spLocks noGrp="1"/>
           </p:cNvSpPr>
@@ -7608,7 +7739,7 @@
       </p:sp>
       <p:sp>
         <p:nvSpPr>
-          <p:cNvPr id="1630594751" name="PlaceHolder 3"/>
+          <p:cNvPr id="1975062668" name="PlaceHolder 3"/>
           <p:cNvSpPr>
             <a:spLocks noGrp="1"/>
           </p:cNvSpPr>
@@ -7683,7 +7814,7 @@
       </p:sp>
       <p:sp>
         <p:nvSpPr>
-          <p:cNvPr id="1862886821" name="PlaceHolder 4"/>
+          <p:cNvPr id="546750100" name="PlaceHolder 4"/>
           <p:cNvSpPr>
             <a:spLocks noGrp="1"/>
           </p:cNvSpPr>
@@ -7756,7 +7887,7 @@
       </p:sp>
       <p:sp>
         <p:nvSpPr>
-          <p:cNvPr id="754290054" name="PlaceHolder 5"/>
+          <p:cNvPr id="1241894792" name="PlaceHolder 5"/>
           <p:cNvSpPr>
             <a:spLocks noGrp="1"/>
           </p:cNvSpPr>
@@ -7864,7 +7995,7 @@
       </p:grpSpPr>
       <p:pic>
         <p:nvPicPr>
-          <p:cNvPr id="2129627840" name="Picture 7" descr="Celestia-R1---OverlayContentHD.png"/>
+          <p:cNvPr id="398364931" name="Picture 7" descr="Celestia-R1---OverlayContentHD.png"/>
           <p:cNvPicPr/>
           <p:nvPr/>
         </p:nvPicPr>
@@ -7888,7 +8019,7 @@
       </p:pic>
       <p:sp>
         <p:nvSpPr>
-          <p:cNvPr id="137013506" name="PlaceHolder 1"/>
+          <p:cNvPr id="1877197048" name="PlaceHolder 1"/>
           <p:cNvSpPr>
             <a:spLocks noGrp="1"/>
           </p:cNvSpPr>
@@ -7963,7 +8094,7 @@
       </p:sp>
       <p:sp>
         <p:nvSpPr>
-          <p:cNvPr id="690362533" name="PlaceHolder 2"/>
+          <p:cNvPr id="1708817029" name="PlaceHolder 2"/>
           <p:cNvSpPr>
             <a:spLocks noGrp="1"/>
           </p:cNvSpPr>
@@ -8254,7 +8385,7 @@
       </p:sp>
       <p:sp>
         <p:nvSpPr>
-          <p:cNvPr id="1907843007" name="PlaceHolder 3"/>
+          <p:cNvPr id="649600860" name="PlaceHolder 3"/>
           <p:cNvSpPr>
             <a:spLocks noGrp="1"/>
           </p:cNvSpPr>
@@ -8545,7 +8676,7 @@
       </p:sp>
       <p:sp>
         <p:nvSpPr>
-          <p:cNvPr id="326895964" name="PlaceHolder 4"/>
+          <p:cNvPr id="100219471" name="PlaceHolder 4"/>
           <p:cNvSpPr>
             <a:spLocks noGrp="1"/>
           </p:cNvSpPr>
@@ -8620,7 +8751,7 @@
       </p:sp>
       <p:sp>
         <p:nvSpPr>
-          <p:cNvPr id="1404869101" name="PlaceHolder 5"/>
+          <p:cNvPr id="1440621278" name="PlaceHolder 5"/>
           <p:cNvSpPr>
             <a:spLocks noGrp="1"/>
           </p:cNvSpPr>
@@ -8693,7 +8824,7 @@
       </p:sp>
       <p:sp>
         <p:nvSpPr>
-          <p:cNvPr id="1763993943" name="PlaceHolder 6"/>
+          <p:cNvPr id="2131499298" name="PlaceHolder 6"/>
           <p:cNvSpPr>
             <a:spLocks noGrp="1"/>
           </p:cNvSpPr>
@@ -8801,7 +8932,7 @@
       </p:grpSpPr>
       <p:sp>
         <p:nvSpPr>
-          <p:cNvPr id="377353415" name="PlaceHolder 1"/>
+          <p:cNvPr id="922864062" name="PlaceHolder 1"/>
           <p:cNvSpPr>
             <a:spLocks noGrp="1"/>
           </p:cNvSpPr>
@@ -8876,7 +9007,7 @@
       </p:sp>
       <p:sp>
         <p:nvSpPr>
-          <p:cNvPr id="130686645" name="PlaceHolder 2"/>
+          <p:cNvPr id="1286662218" name="PlaceHolder 2"/>
           <p:cNvSpPr>
             <a:spLocks noGrp="1"/>
           </p:cNvSpPr>
@@ -8957,7 +9088,7 @@
       </p:sp>
       <p:sp>
         <p:nvSpPr>
-          <p:cNvPr id="347155234" name="PlaceHolder 3"/>
+          <p:cNvPr id="1186186303" name="PlaceHolder 3"/>
           <p:cNvSpPr>
             <a:spLocks noGrp="1"/>
           </p:cNvSpPr>
@@ -9278,7 +9409,7 @@
       </p:sp>
       <p:sp>
         <p:nvSpPr>
-          <p:cNvPr id="1692716225" name="PlaceHolder 4"/>
+          <p:cNvPr id="235992920" name="PlaceHolder 4"/>
           <p:cNvSpPr>
             <a:spLocks noGrp="1"/>
           </p:cNvSpPr>
@@ -9359,7 +9490,7 @@
       </p:sp>
       <p:sp>
         <p:nvSpPr>
-          <p:cNvPr id="189043785" name="PlaceHolder 5"/>
+          <p:cNvPr id="262904532" name="PlaceHolder 5"/>
           <p:cNvSpPr>
             <a:spLocks noGrp="1"/>
           </p:cNvSpPr>
@@ -9680,7 +9811,7 @@
       </p:sp>
       <p:sp>
         <p:nvSpPr>
-          <p:cNvPr id="863735072" name="PlaceHolder 6"/>
+          <p:cNvPr id="1491311261" name="PlaceHolder 6"/>
           <p:cNvSpPr>
             <a:spLocks noGrp="1"/>
           </p:cNvSpPr>
@@ -9755,7 +9886,7 @@
       </p:sp>
       <p:sp>
         <p:nvSpPr>
-          <p:cNvPr id="961489854" name="PlaceHolder 7"/>
+          <p:cNvPr id="1384307306" name="PlaceHolder 7"/>
           <p:cNvSpPr>
             <a:spLocks noGrp="1"/>
           </p:cNvSpPr>
@@ -9828,7 +9959,7 @@
       </p:sp>
       <p:sp>
         <p:nvSpPr>
-          <p:cNvPr id="1698938578" name="PlaceHolder 8"/>
+          <p:cNvPr id="323466892" name="PlaceHolder 8"/>
           <p:cNvSpPr>
             <a:spLocks noGrp="1"/>
           </p:cNvSpPr>
@@ -9936,7 +10067,7 @@
       </p:grpSpPr>
       <p:pic>
         <p:nvPicPr>
-          <p:cNvPr id="1874702823" name="Picture 5" descr="Celestia-R1---OverlayContentHD.png"/>
+          <p:cNvPr id="1306078648" name="Picture 5" descr="Celestia-R1---OverlayContentHD.png"/>
           <p:cNvPicPr/>
           <p:nvPr/>
         </p:nvPicPr>
@@ -9960,7 +10091,7 @@
       </p:pic>
       <p:sp>
         <p:nvSpPr>
-          <p:cNvPr id="1529536230" name="PlaceHolder 1"/>
+          <p:cNvPr id="692254665" name="PlaceHolder 1"/>
           <p:cNvSpPr>
             <a:spLocks noGrp="1"/>
           </p:cNvSpPr>
@@ -10035,7 +10166,7 @@
       </p:sp>
       <p:sp>
         <p:nvSpPr>
-          <p:cNvPr id="75737894" name="PlaceHolder 2"/>
+          <p:cNvPr id="1856882931" name="PlaceHolder 2"/>
           <p:cNvSpPr>
             <a:spLocks noGrp="1"/>
           </p:cNvSpPr>
@@ -10110,7 +10241,7 @@
       </p:sp>
       <p:sp>
         <p:nvSpPr>
-          <p:cNvPr id="1752501391" name="PlaceHolder 3"/>
+          <p:cNvPr id="1819576051" name="PlaceHolder 3"/>
           <p:cNvSpPr>
             <a:spLocks noGrp="1"/>
           </p:cNvSpPr>
@@ -10183,7 +10314,7 @@
       </p:sp>
       <p:sp>
         <p:nvSpPr>
-          <p:cNvPr id="800115211" name="PlaceHolder 4"/>
+          <p:cNvPr id="352058999" name="PlaceHolder 4"/>
           <p:cNvSpPr>
             <a:spLocks noGrp="1"/>
           </p:cNvSpPr>
@@ -10291,7 +10422,7 @@
       </p:grpSpPr>
       <p:pic>
         <p:nvPicPr>
-          <p:cNvPr id="653012042" name="Picture 4" descr="Celestia-R1---OverlayContentHD.png"/>
+          <p:cNvPr id="1319428425" name="Picture 4" descr="Celestia-R1---OverlayContentHD.png"/>
           <p:cNvPicPr/>
           <p:nvPr/>
         </p:nvPicPr>
@@ -10315,7 +10446,7 @@
       </p:pic>
       <p:sp>
         <p:nvSpPr>
-          <p:cNvPr id="1485500051" name="PlaceHolder 1"/>
+          <p:cNvPr id="1257541880" name="PlaceHolder 1"/>
           <p:cNvSpPr>
             <a:spLocks noGrp="1"/>
           </p:cNvSpPr>
@@ -10390,7 +10521,7 @@
       </p:sp>
       <p:sp>
         <p:nvSpPr>
-          <p:cNvPr id="951532053" name="PlaceHolder 2"/>
+          <p:cNvPr id="1902301619" name="PlaceHolder 2"/>
           <p:cNvSpPr>
             <a:spLocks noGrp="1"/>
           </p:cNvSpPr>
@@ -10463,7 +10594,7 @@
       </p:sp>
       <p:sp>
         <p:nvSpPr>
-          <p:cNvPr id="1137338044" name="PlaceHolder 3"/>
+          <p:cNvPr id="828345001" name="PlaceHolder 3"/>
           <p:cNvSpPr>
             <a:spLocks noGrp="1"/>
           </p:cNvSpPr>
@@ -10571,7 +10702,7 @@
       </p:grpSpPr>
       <p:pic>
         <p:nvPicPr>
-          <p:cNvPr id="170205319" name="Picture 7" descr="Celestia-R1---OverlayContentHD.png"/>
+          <p:cNvPr id="879006648" name="Picture 7" descr="Celestia-R1---OverlayContentHD.png"/>
           <p:cNvPicPr/>
           <p:nvPr/>
         </p:nvPicPr>
@@ -10595,7 +10726,7 @@
       </p:pic>
       <p:sp>
         <p:nvSpPr>
-          <p:cNvPr id="1277898866" name="PlaceHolder 1"/>
+          <p:cNvPr id="1612527061" name="PlaceHolder 1"/>
           <p:cNvSpPr>
             <a:spLocks noGrp="1"/>
           </p:cNvSpPr>
@@ -10670,7 +10801,7 @@
       </p:sp>
       <p:sp>
         <p:nvSpPr>
-          <p:cNvPr id="1675310561" name="PlaceHolder 2"/>
+          <p:cNvPr id="697593319" name="PlaceHolder 2"/>
           <p:cNvSpPr>
             <a:spLocks noGrp="1"/>
           </p:cNvSpPr>
@@ -10961,7 +11092,7 @@
       </p:sp>
       <p:sp>
         <p:nvSpPr>
-          <p:cNvPr id="796672400" name="PlaceHolder 3"/>
+          <p:cNvPr id="645168075" name="PlaceHolder 3"/>
           <p:cNvSpPr>
             <a:spLocks noGrp="1"/>
           </p:cNvSpPr>
@@ -11042,7 +11173,7 @@
       </p:sp>
       <p:sp>
         <p:nvSpPr>
-          <p:cNvPr id="423465094" name="PlaceHolder 4"/>
+          <p:cNvPr id="2145514791" name="PlaceHolder 4"/>
           <p:cNvSpPr>
             <a:spLocks noGrp="1"/>
           </p:cNvSpPr>
@@ -11117,7 +11248,7 @@
       </p:sp>
       <p:sp>
         <p:nvSpPr>
-          <p:cNvPr id="1191643566" name="PlaceHolder 5"/>
+          <p:cNvPr id="462501948" name="PlaceHolder 5"/>
           <p:cNvSpPr>
             <a:spLocks noGrp="1"/>
           </p:cNvSpPr>
@@ -11190,7 +11321,7 @@
       </p:sp>
       <p:sp>
         <p:nvSpPr>
-          <p:cNvPr id="646726754" name="PlaceHolder 6"/>
+          <p:cNvPr id="1714469371" name="PlaceHolder 6"/>
           <p:cNvSpPr>
             <a:spLocks noGrp="1"/>
           </p:cNvSpPr>
@@ -11298,7 +11429,7 @@
       </p:grpSpPr>
       <p:pic>
         <p:nvPicPr>
-          <p:cNvPr id="2076063653" name="Picture 7" descr="Celestia-R1---OverlayContentHD.png"/>
+          <p:cNvPr id="1981756811" name="Picture 7" descr="Celestia-R1---OverlayContentHD.png"/>
           <p:cNvPicPr/>
           <p:nvPr/>
         </p:nvPicPr>
@@ -11322,7 +11453,7 @@
       </p:pic>
       <p:sp>
         <p:nvSpPr>
-          <p:cNvPr id="1537149768" name="PlaceHolder 1"/>
+          <p:cNvPr id="9632777" name="PlaceHolder 1"/>
           <p:cNvSpPr>
             <a:spLocks noGrp="1"/>
           </p:cNvSpPr>
@@ -11397,7 +11528,7 @@
       </p:sp>
       <p:sp>
         <p:nvSpPr>
-          <p:cNvPr id="1920509860" name="PlaceHolder 2"/>
+          <p:cNvPr id="1452801701" name="PlaceHolder 2"/>
           <p:cNvSpPr>
             <a:spLocks noGrp="1"/>
           </p:cNvSpPr>
@@ -11482,7 +11613,7 @@
       </p:sp>
       <p:sp>
         <p:nvSpPr>
-          <p:cNvPr id="1734767483" name="PlaceHolder 3"/>
+          <p:cNvPr id="1729644968" name="PlaceHolder 3"/>
           <p:cNvSpPr>
             <a:spLocks noGrp="1"/>
           </p:cNvSpPr>
@@ -11563,7 +11694,7 @@
       </p:sp>
       <p:sp>
         <p:nvSpPr>
-          <p:cNvPr id="2033373279" name="PlaceHolder 4"/>
+          <p:cNvPr id="1359153143" name="PlaceHolder 4"/>
           <p:cNvSpPr>
             <a:spLocks noGrp="1"/>
           </p:cNvSpPr>
@@ -11638,7 +11769,7 @@
       </p:sp>
       <p:sp>
         <p:nvSpPr>
-          <p:cNvPr id="1771010591" name="PlaceHolder 5"/>
+          <p:cNvPr id="1839039332" name="PlaceHolder 5"/>
           <p:cNvSpPr>
             <a:spLocks noGrp="1"/>
           </p:cNvSpPr>
@@ -11711,7 +11842,7 @@
       </p:sp>
       <p:sp>
         <p:nvSpPr>
-          <p:cNvPr id="807174562" name="PlaceHolder 6"/>
+          <p:cNvPr id="2047161739" name="PlaceHolder 6"/>
           <p:cNvSpPr>
             <a:spLocks noGrp="1"/>
           </p:cNvSpPr>
@@ -11861,7 +11992,7 @@
       </p:grpSpPr>
       <p:sp>
         <p:nvSpPr>
-          <p:cNvPr id="1639837478" name="PlaceHolder 1"/>
+          <p:cNvPr id="682816155" name="PlaceHolder 1"/>
           <p:cNvSpPr>
             <a:spLocks noGrp="1"/>
           </p:cNvSpPr>
@@ -11921,7 +12052,7 @@
       </p:sp>
       <p:sp>
         <p:nvSpPr>
-          <p:cNvPr id="1136629129" name="Picture 7" descr="A blue text on a black background&#10;&#10;Description automatically generated"/>
+          <p:cNvPr id="377653816" name="Picture 7" descr="A blue text on a black background&#10;&#10;Description automatically generated"/>
           <p:cNvSpPr/>
           <p:nvPr/>
         </p:nvSpPr>
@@ -11970,6 +12101,540 @@
             <a:endParaRPr lang="en-US" sz="1800" b="0" u="none" strike="noStrike">
               <a:solidFill>
                 <a:srgbClr val="000000"/>
+              </a:solidFill>
+              <a:latin typeface="Arial"/>
+            </a:endParaRPr>
+          </a:p>
+        </p:txBody>
+      </p:sp>
+    </p:spTree>
+  </p:cSld>
+  <p:clrMapOvr>
+    <a:masterClrMapping/>
+  </p:clrMapOvr>
+  <mc:AlternateContent xmlns:mc="http://schemas.openxmlformats.org/markup-compatibility/2006">
+    <mc:Choice xmlns:p159="http://schemas.microsoft.com/office/powerpoint/2015/09/main" xmlns:p14="http://schemas.microsoft.com/office/powerpoint/2010/main" Requires="p159">
+      <p:transition p14:dur="2000" advClick="1"/>
+    </mc:Choice>
+    <mc:Fallback>
+      <p:transition advClick="1"/>
+    </mc:Fallback>
+  </mc:AlternateContent>
+</p:sld>
+</file>
+
+<file path=ppt/slides/slide10.xml><?xml version="1.0" encoding="utf-8"?>
+<p:sld xmlns:a="http://schemas.openxmlformats.org/drawingml/2006/main" xmlns:r="http://schemas.openxmlformats.org/officeDocument/2006/relationships" xmlns:p="http://schemas.openxmlformats.org/presentationml/2006/main" xmlns:m="http://schemas.openxmlformats.org/officeDocument/2006/math" xmlns:w="http://schemas.openxmlformats.org/wordprocessingml/2006/main" xmlns:mc="http://schemas.openxmlformats.org/markup-compatibility/2006" showMasterPhAnim="0" showMasterSp="1" show="1">
+  <p:cSld name="">
+    <p:spTree>
+      <p:nvGrpSpPr>
+        <p:cNvPr id="1" name=""/>
+        <p:cNvGrpSpPr/>
+        <p:nvPr/>
+      </p:nvGrpSpPr>
+      <p:grpSpPr bwMode="auto">
+        <a:xfrm>
+          <a:off x="0" y="0"/>
+          <a:ext cx="0" cy="0"/>
+          <a:chOff x="0" y="0"/>
+          <a:chExt cx="0" cy="0"/>
+        </a:xfrm>
+      </p:grpSpPr>
+      <p:sp>
+        <p:nvSpPr>
+          <p:cNvPr id="1944029085" name="PlaceHolder 1"/>
+          <p:cNvSpPr>
+            <a:spLocks noGrp="1"/>
+          </p:cNvSpPr>
+          <p:nvPr>
+            <p:ph/>
+          </p:nvPr>
+        </p:nvSpPr>
+        <p:spPr bwMode="auto">
+          <a:xfrm>
+            <a:off x="884879" y="-131760"/>
+            <a:ext cx="10130760" cy="1566720"/>
+          </a:xfrm>
+          <a:prstGeom prst="rect">
+            <a:avLst/>
+          </a:prstGeom>
+          <a:noFill/>
+          <a:ln w="0">
+            <a:noFill/>
+          </a:ln>
+        </p:spPr>
+        <p:txBody>
+          <a:bodyPr lIns="91440" tIns="45720" rIns="91440" bIns="45720" anchor="ctr">
+            <a:normAutofit/>
+          </a:bodyPr>
+          <a:p>
+            <a:pPr indent="0" algn="ctr" defTabSz="457200">
+              <a:lnSpc>
+                <a:spcPct val="100000"/>
+              </a:lnSpc>
+              <a:spcAft>
+                <a:spcPts val="1001"/>
+              </a:spcAft>
+              <a:buNone/>
+              <a:tabLst>
+                <a:tab pos="0" algn="l"/>
+              </a:tabLst>
+              <a:defRPr/>
+            </a:pPr>
+            <a:r>
+              <a:rPr lang="en-US" sz="5400" b="1" u="none" strike="noStrike">
+                <a:solidFill>
+                  <a:schemeClr val="lt1"/>
+                </a:solidFill>
+                <a:latin typeface="Times New Roman"/>
+                <a:ea typeface="Arial"/>
+              </a:rPr>
+              <a:t>How to Play</a:t>
+            </a:r>
+            <a:endParaRPr lang="en-US" sz="5400" b="0" u="none" strike="noStrike">
+              <a:solidFill>
+                <a:schemeClr val="lt1"/>
+              </a:solidFill>
+              <a:latin typeface="Calibri"/>
+            </a:endParaRPr>
+          </a:p>
+        </p:txBody>
+      </p:sp>
+      <p:sp>
+        <p:nvSpPr>
+          <p:cNvPr id="1000643669" name="TextBox 3"/>
+          <p:cNvSpPr/>
+          <p:nvPr/>
+        </p:nvSpPr>
+        <p:spPr bwMode="auto">
+          <a:xfrm>
+            <a:off x="1030320" y="1212480"/>
+            <a:ext cx="10144800" cy="2307600"/>
+          </a:xfrm>
+          <a:prstGeom prst="rect">
+            <a:avLst/>
+          </a:prstGeom>
+          <a:noFill/>
+          <a:ln w="0">
+            <a:noFill/>
+          </a:ln>
+        </p:spPr>
+        <p:style>
+          <a:lnRef idx="0"/>
+          <a:fillRef idx="0"/>
+          <a:effectRef idx="0"/>
+          <a:fontRef idx="minor"/>
+        </p:style>
+        <p:txBody>
+          <a:bodyPr lIns="90000" tIns="45000" rIns="90000" bIns="45000" anchor="t">
+            <a:spAutoFit/>
+          </a:bodyPr>
+          <a:p>
+            <a:pPr marL="343080" indent="-343080" defTabSz="457200">
+              <a:lnSpc>
+                <a:spcPct val="100000"/>
+              </a:lnSpc>
+              <a:buClr>
+                <a:srgbClr val="FFFFFF"/>
+              </a:buClr>
+              <a:buFont typeface="Calibri Light"/>
+              <a:buAutoNum type="arabicPeriod"/>
+              <a:defRPr/>
+            </a:pPr>
+            <a:r>
+              <a:rPr lang="en-US" sz="2400" b="0" u="none" strike="noStrike">
+                <a:solidFill>
+                  <a:schemeClr val="lt1"/>
+                </a:solidFill>
+                <a:latin typeface="Times New Roman"/>
+                <a:ea typeface="Arial"/>
+              </a:rPr>
+              <a:t>Ensure that all raspberry pis are on the same network and that python is installed on hardware</a:t>
+            </a:r>
+            <a:endParaRPr lang="en-US" sz="2400" b="0" u="none" strike="noStrike">
+              <a:solidFill>
+                <a:srgbClr val="FFFFFF"/>
+              </a:solidFill>
+              <a:latin typeface="Arial"/>
+            </a:endParaRPr>
+          </a:p>
+          <a:p>
+            <a:pPr marL="343080" indent="-343080" defTabSz="457200">
+              <a:lnSpc>
+                <a:spcPct val="100000"/>
+              </a:lnSpc>
+              <a:buClr>
+                <a:srgbClr val="FFFFFF"/>
+              </a:buClr>
+              <a:buFont typeface="Calibri Light"/>
+              <a:buAutoNum type="arabicPeriod"/>
+              <a:defRPr/>
+            </a:pPr>
+            <a:r>
+              <a:rPr lang="en-US" sz="2400" b="0" u="none" strike="noStrike">
+                <a:solidFill>
+                  <a:schemeClr val="lt1"/>
+                </a:solidFill>
+                <a:latin typeface="Times New Roman"/>
+                <a:ea typeface="Arial"/>
+              </a:rPr>
+              <a:t> Launch the game (host): open the terminal and navigate to the game folder</a:t>
+            </a:r>
+            <a:endParaRPr lang="en-US" sz="2400" b="0" u="none" strike="noStrike">
+              <a:solidFill>
+                <a:srgbClr val="FFFFFF"/>
+              </a:solidFill>
+              <a:latin typeface="Arial"/>
+            </a:endParaRPr>
+          </a:p>
+          <a:p>
+            <a:pPr marL="343080" indent="-343080" defTabSz="457200">
+              <a:lnSpc>
+                <a:spcPct val="100000"/>
+              </a:lnSpc>
+              <a:buClr>
+                <a:srgbClr val="FFFFFF"/>
+              </a:buClr>
+              <a:buFont typeface="Calibri Light"/>
+              <a:buAutoNum type="arabicPeriod"/>
+              <a:defRPr/>
+            </a:pPr>
+            <a:r>
+              <a:rPr lang="en-US" sz="2400" b="0" u="none" strike="noStrike">
+                <a:solidFill>
+                  <a:schemeClr val="lt1"/>
+                </a:solidFill>
+                <a:latin typeface="Times New Roman"/>
+                <a:ea typeface="Arial"/>
+              </a:rPr>
+              <a:t> launch the game (player): open the terminal and navigate to the game folder. When prompted type the host’s IP address to join the game.</a:t>
+            </a:r>
+            <a:endParaRPr lang="en-US" sz="2400" b="0" u="none" strike="noStrike">
+              <a:solidFill>
+                <a:srgbClr val="FFFFFF"/>
+              </a:solidFill>
+              <a:latin typeface="Arial"/>
+            </a:endParaRPr>
+          </a:p>
+          <a:p>
+            <a:pPr marL="343080" indent="-343080" defTabSz="457200">
+              <a:lnSpc>
+                <a:spcPct val="100000"/>
+              </a:lnSpc>
+              <a:buClr>
+                <a:srgbClr val="FFFFFF"/>
+              </a:buClr>
+              <a:buFont typeface="Calibri Light"/>
+              <a:buAutoNum type="arabicPeriod"/>
+              <a:defRPr/>
+            </a:pPr>
+            <a:r>
+              <a:rPr lang="en-US" sz="2400" b="0" u="none" strike="noStrike">
+                <a:solidFill>
+                  <a:schemeClr val="lt1"/>
+                </a:solidFill>
+                <a:latin typeface="Times New Roman"/>
+                <a:ea typeface="Arial"/>
+              </a:rPr>
+              <a:t> </a:t>
+            </a:r>
+            <a:endParaRPr lang="en-US" sz="2400" b="0" u="none" strike="noStrike">
+              <a:solidFill>
+                <a:srgbClr val="FFFFFF"/>
+              </a:solidFill>
+              <a:latin typeface="Arial"/>
+            </a:endParaRPr>
+          </a:p>
+        </p:txBody>
+      </p:sp>
+      <p:pic>
+        <p:nvPicPr>
+          <p:cNvPr id="374357700" name="Picture 5" descr="A screenshot of a computer&#10;&#10;Description automatically generated"/>
+          <p:cNvPicPr/>
+          <p:nvPr/>
+        </p:nvPicPr>
+        <p:blipFill rotWithShape="1">
+          <a:blip r:embed="rId3"/>
+          <a:stretch/>
+        </p:blipFill>
+        <p:spPr bwMode="auto">
+          <a:xfrm>
+            <a:off x="1465200" y="3207600"/>
+            <a:ext cx="7771680" cy="1725120"/>
+          </a:xfrm>
+          <a:prstGeom prst="rect">
+            <a:avLst/>
+          </a:prstGeom>
+          <a:noFill/>
+          <a:ln w="0">
+            <a:noFill/>
+          </a:ln>
+        </p:spPr>
+      </p:pic>
+      <p:sp>
+        <p:nvSpPr>
+          <p:cNvPr id="981731953" name="TextBox 6"/>
+          <p:cNvSpPr/>
+          <p:nvPr/>
+        </p:nvSpPr>
+        <p:spPr bwMode="auto">
+          <a:xfrm>
+            <a:off x="968760" y="4933440"/>
+            <a:ext cx="9525240" cy="460800"/>
+          </a:xfrm>
+          <a:prstGeom prst="rect">
+            <a:avLst/>
+          </a:prstGeom>
+          <a:noFill/>
+          <a:ln w="0">
+            <a:noFill/>
+          </a:ln>
+        </p:spPr>
+        <p:style>
+          <a:lnRef idx="0"/>
+          <a:fillRef idx="0"/>
+          <a:effectRef idx="0"/>
+          <a:fontRef idx="minor"/>
+        </p:style>
+        <p:txBody>
+          <a:bodyPr lIns="90000" tIns="45000" rIns="90000" bIns="45000" anchor="t">
+            <a:spAutoFit/>
+          </a:bodyPr>
+          <a:p>
+            <a:pPr defTabSz="457200">
+              <a:lnSpc>
+                <a:spcPct val="100000"/>
+              </a:lnSpc>
+              <a:defRPr/>
+            </a:pPr>
+            <a:r>
+              <a:rPr lang="en-US" sz="2400" b="0" u="none" strike="noStrike">
+                <a:solidFill>
+                  <a:schemeClr val="lt1"/>
+                </a:solidFill>
+                <a:latin typeface="Times New Roman"/>
+                <a:ea typeface="Arial"/>
+              </a:rPr>
+              <a:t>5. Let’s play!</a:t>
+            </a:r>
+            <a:endParaRPr lang="en-US" sz="2400" b="0" u="none" strike="noStrike">
+              <a:solidFill>
+                <a:srgbClr val="FFFFFF"/>
+              </a:solidFill>
+              <a:latin typeface="Arial"/>
+            </a:endParaRPr>
+          </a:p>
+        </p:txBody>
+      </p:sp>
+      <p:pic>
+        <p:nvPicPr>
+          <p:cNvPr id="1308162058" name="Picture 5" descr="A screenshot of a computer&#10;&#10;Description automatically generated"/>
+          <p:cNvPicPr/>
+          <p:nvPr/>
+        </p:nvPicPr>
+        <p:blipFill rotWithShape="1">
+          <a:blip r:embed="rId3"/>
+          <a:srcRect l="74536" t="81275" r="1751" b="3995"/>
+          <a:stretch/>
+        </p:blipFill>
+        <p:spPr bwMode="auto">
+          <a:xfrm>
+            <a:off x="1519920" y="4260600"/>
+            <a:ext cx="2514240" cy="253080"/>
+          </a:xfrm>
+          <a:prstGeom prst="rect">
+            <a:avLst/>
+          </a:prstGeom>
+          <a:noFill/>
+          <a:ln w="0">
+            <a:noFill/>
+          </a:ln>
+        </p:spPr>
+      </p:pic>
+      <p:pic>
+        <p:nvPicPr>
+          <p:cNvPr id="241287427" name="Picture 1" descr="A screenshot of a computer&#10;&#10;Description automatically generated"/>
+          <p:cNvPicPr/>
+          <p:nvPr/>
+        </p:nvPicPr>
+        <p:blipFill rotWithShape="1">
+          <a:blip r:embed="rId3"/>
+          <a:srcRect l="74536" t="81275" r="1751" b="3995"/>
+          <a:stretch/>
+        </p:blipFill>
+        <p:spPr bwMode="auto">
+          <a:xfrm>
+            <a:off x="5704560" y="4273560"/>
+            <a:ext cx="2514240" cy="253080"/>
+          </a:xfrm>
+          <a:prstGeom prst="rect">
+            <a:avLst/>
+          </a:prstGeom>
+          <a:noFill/>
+          <a:ln w="0">
+            <a:noFill/>
+          </a:ln>
+        </p:spPr>
+      </p:pic>
+      <p:sp>
+        <p:nvSpPr>
+          <p:cNvPr id="668773977" name=""/>
+          <p:cNvSpPr/>
+          <p:nvPr/>
+        </p:nvSpPr>
+        <p:spPr bwMode="auto">
+          <a:xfrm>
+            <a:off x="5679000" y="4275000"/>
+            <a:ext cx="1407240" cy="373680"/>
+          </a:xfrm>
+          <a:prstGeom prst="rect">
+            <a:avLst/>
+          </a:prstGeom>
+          <a:noFill/>
+          <a:ln w="0">
+            <a:noFill/>
+          </a:ln>
+        </p:spPr>
+        <p:style>
+          <a:lnRef idx="0"/>
+          <a:fillRef idx="0"/>
+          <a:effectRef idx="0"/>
+          <a:fontRef idx="minor"/>
+        </p:style>
+        <p:txBody>
+          <a:bodyPr lIns="90000" tIns="45000" rIns="90000" bIns="45000" anchor="t">
+            <a:spAutoFit/>
+          </a:bodyPr>
+          <a:p>
+            <a:pPr>
+              <a:lnSpc>
+                <a:spcPct val="100000"/>
+              </a:lnSpc>
+              <a:defRPr/>
+            </a:pPr>
+            <a:r>
+              <a:rPr lang="en-US" sz="950" b="0" u="none" strike="noStrike">
+                <a:solidFill>
+                  <a:srgbClr val="FFFFFF"/>
+                </a:solidFill>
+                <a:latin typeface="Arial"/>
+              </a:rPr>
+              <a:t>Use </a:t>
+            </a:r>
+            <a:r>
+              <a:rPr lang="en-US" sz="950" b="1" u="none" strike="noStrike">
+                <a:solidFill>
+                  <a:srgbClr val="FFFFFF"/>
+                </a:solidFill>
+                <a:latin typeface="Arial"/>
+              </a:rPr>
+              <a:t>WASD</a:t>
+            </a:r>
+            <a:r>
+              <a:rPr lang="en-US" sz="950" b="0" u="none" strike="noStrike">
+                <a:solidFill>
+                  <a:srgbClr val="FFFFFF"/>
+                </a:solidFill>
+                <a:latin typeface="Arial"/>
+              </a:rPr>
+              <a:t> to move</a:t>
+            </a:r>
+            <a:endParaRPr lang="en-US" sz="950" b="0" u="none" strike="noStrike">
+              <a:solidFill>
+                <a:srgbClr val="FFFFFF"/>
+              </a:solidFill>
+              <a:latin typeface="Arial"/>
+            </a:endParaRPr>
+          </a:p>
+        </p:txBody>
+      </p:sp>
+      <p:sp>
+        <p:nvSpPr>
+          <p:cNvPr id="1703243060" name=""/>
+          <p:cNvSpPr/>
+          <p:nvPr/>
+        </p:nvSpPr>
+        <p:spPr bwMode="auto">
+          <a:xfrm>
+            <a:off x="1483920" y="4275360"/>
+            <a:ext cx="2514240" cy="235080"/>
+          </a:xfrm>
+          <a:prstGeom prst="rect">
+            <a:avLst/>
+          </a:prstGeom>
+          <a:noFill/>
+          <a:ln w="0">
+            <a:noFill/>
+          </a:ln>
+        </p:spPr>
+        <p:style>
+          <a:lnRef idx="0"/>
+          <a:fillRef idx="0"/>
+          <a:effectRef idx="0"/>
+          <a:fontRef idx="minor"/>
+        </p:style>
+        <p:txBody>
+          <a:bodyPr lIns="90000" tIns="45000" rIns="90000" bIns="45000" anchor="t">
+            <a:spAutoFit/>
+          </a:bodyPr>
+          <a:p>
+            <a:pPr>
+              <a:lnSpc>
+                <a:spcPct val="100000"/>
+              </a:lnSpc>
+              <a:defRPr/>
+            </a:pPr>
+            <a:r>
+              <a:rPr lang="en-US" sz="950" b="0" u="none" strike="noStrike">
+                <a:solidFill>
+                  <a:srgbClr val="FFFFFF"/>
+                </a:solidFill>
+                <a:latin typeface="Arial"/>
+                <a:ea typeface="Noto Sans CJK SC"/>
+              </a:rPr>
+              <a:t> </a:t>
+            </a:r>
+            <a:r>
+              <a:rPr lang="en-US" sz="950" b="1" u="none" strike="noStrike">
+                <a:solidFill>
+                  <a:srgbClr val="FFFFFF"/>
+                </a:solidFill>
+                <a:latin typeface="Arial"/>
+                <a:ea typeface="Noto Sans CJK SC"/>
+              </a:rPr>
+              <a:t>PacMan Chase</a:t>
+            </a:r>
+            <a:r>
+              <a:rPr lang="en-US" sz="950" b="0" u="none" strike="noStrike">
+                <a:solidFill>
+                  <a:srgbClr val="FFFFFF"/>
+                </a:solidFill>
+                <a:latin typeface="Arial"/>
+                <a:ea typeface="Noto Sans CJK SC"/>
+              </a:rPr>
+              <a:t> </a:t>
+            </a:r>
+            <a:r>
+              <a:rPr lang="en-US" sz="950" b="0" u="none" strike="noStrike">
+                <a:solidFill>
+                  <a:srgbClr val="FFFFFF"/>
+                </a:solidFill>
+                <a:latin typeface="Arial"/>
+              </a:rPr>
+              <a:t>and the </a:t>
+            </a:r>
+            <a:r>
+              <a:rPr lang="en-US" sz="950" b="1" u="none" strike="noStrike">
+                <a:solidFill>
+                  <a:srgbClr val="FFFFFF"/>
+                </a:solidFill>
+                <a:latin typeface="Arial"/>
+              </a:rPr>
+              <a:t>Snake Game</a:t>
+            </a:r>
+            <a:endParaRPr lang="en-US" sz="950" b="0" u="none" strike="noStrike">
+              <a:solidFill>
+                <a:srgbClr val="FFFFFF"/>
               </a:solidFill>
               <a:latin typeface="Arial"/>
             </a:endParaRPr>
@@ -12011,7 +12676,7 @@
       </p:grpSpPr>
       <p:sp>
         <p:nvSpPr>
-          <p:cNvPr id="2034273804" name="PlaceHolder 1"/>
+          <p:cNvPr id="1370516690" name="PlaceHolder 1"/>
           <p:cNvSpPr>
             <a:spLocks noGrp="1"/>
           </p:cNvSpPr>
@@ -12068,7 +12733,7 @@
       </p:sp>
       <p:sp>
         <p:nvSpPr>
-          <p:cNvPr id="834685787" name="PlaceHolder 2"/>
+          <p:cNvPr id="1723426621" name="PlaceHolder 2"/>
           <p:cNvSpPr>
             <a:spLocks noGrp="1"/>
           </p:cNvSpPr>
@@ -12233,24 +12898,26 @@
               <a:defRPr/>
             </a:pPr>
             <a:r>
-              <a:rPr lang="en-US" sz="2400" b="1" u="none" strike="noStrike">
+              <a:rPr lang="en-US" sz="2400" b="1" i="0" u="none" strike="noStrike" cap="none" spc="0">
                 <a:solidFill>
                   <a:schemeClr val="lt1"/>
                 </a:solidFill>
                 <a:latin typeface="Times New Roman"/>
-                <a:ea typeface="Arial"/>
+                <a:ea typeface="Times New Roman"/>
+                <a:cs typeface="Times New Roman"/>
               </a:rPr>
               <a:t>TCP/IP Networking:</a:t>
             </a:r>
             <a:r>
-              <a:rPr lang="en-US" sz="2400" b="0" u="none" strike="noStrike">
+              <a:rPr lang="en-US" sz="2400" b="0" i="0" u="none" strike="noStrike" cap="none" spc="0">
                 <a:solidFill>
                   <a:schemeClr val="lt1"/>
                 </a:solidFill>
                 <a:latin typeface="Times New Roman"/>
-                <a:ea typeface="Arial"/>
-              </a:rPr>
-              <a:t> Uses "Transmission Control Protocol" to ensure game data (like moves and scores) arrives reliably and in the correct order across the local network.</a:t>
+                <a:ea typeface="Times New Roman"/>
+                <a:cs typeface="Times New Roman"/>
+              </a:rPr>
+              <a:t> Uses the Transmission Control Protocol (TCP) over port 65432 to ensure game data, player actions, and scores arrive reliably and in the correct order across the local network.</a:t>
             </a:r>
             <a:endParaRPr lang="en-US" sz="2400" b="0" u="none" strike="noStrike">
               <a:solidFill>
@@ -12442,7 +13109,7 @@
       </p:grpSpPr>
       <p:sp>
         <p:nvSpPr>
-          <p:cNvPr id="2006585884" name="PlaceHolder 1"/>
+          <p:cNvPr id="139744347" name="PlaceHolder 1"/>
           <p:cNvSpPr>
             <a:spLocks noGrp="1"/>
           </p:cNvSpPr>
@@ -12464,8 +13131,8 @@
           </a:ln>
         </p:spPr>
         <p:txBody>
-          <a:bodyPr lIns="91440" tIns="45720" rIns="91440" bIns="45720" anchor="ctr">
-            <a:normAutofit fontScale="92500" lnSpcReduction="9999"/>
+          <a:bodyPr vertOverflow="overflow" horzOverflow="overflow" vert="horz" wrap="square" lIns="91440" tIns="45720" rIns="91440" bIns="45720" numCol="1" spcCol="0" rtlCol="0" fromWordArt="0" anchor="ctr" anchorCtr="0" forceAA="0" upright="0" compatLnSpc="0">
+            <a:normAutofit/>
           </a:bodyPr>
           <a:p>
             <a:pPr indent="0" algn="ctr" defTabSz="457200">
@@ -12479,14 +13146,15 @@
               <a:defRPr/>
             </a:pPr>
             <a:r>
-              <a:rPr lang="en-US" sz="5400" b="1" u="none" strike="noStrike" cap="all">
+              <a:rPr lang="en-US" sz="5000" b="1" i="0" u="none" strike="noStrike" cap="all" spc="0">
                 <a:solidFill>
                   <a:schemeClr val="lt1"/>
                 </a:solidFill>
                 <a:latin typeface="Times New Roman"/>
-                <a:ea typeface="Arial"/>
-              </a:rPr>
-              <a:t>Game Security</a:t>
+                <a:ea typeface="Times New Roman"/>
+                <a:cs typeface="Times New Roman"/>
+              </a:rPr>
+              <a:t>Authentication Security</a:t>
             </a:r>
             <a:endParaRPr lang="en-US" sz="5400" b="0" u="none" strike="noStrike" cap="all">
               <a:solidFill>
@@ -12499,7 +13167,7 @@
       </p:sp>
       <p:sp>
         <p:nvSpPr>
-          <p:cNvPr id="1741450215" name="PlaceHolder 2"/>
+          <p:cNvPr id="1430289986" name="PlaceHolder 2"/>
           <p:cNvSpPr>
             <a:spLocks noGrp="1"/>
           </p:cNvSpPr>
@@ -12509,8 +13177,8 @@
         </p:nvSpPr>
         <p:spPr bwMode="auto">
           <a:xfrm rot="0" flipH="0" flipV="0">
-            <a:off x="649223" y="1052285"/>
-            <a:ext cx="10709280" cy="5361213"/>
+            <a:off x="649222" y="1052284"/>
+            <a:ext cx="10709280" cy="5361212"/>
           </a:xfrm>
           <a:prstGeom prst="rect">
             <a:avLst/>
@@ -12530,7 +13198,7 @@
                 <a:spcPct val="100000"/>
               </a:lnSpc>
               <a:spcAft>
-                <a:spcPts val="1000"/>
+                <a:spcPts val="999"/>
               </a:spcAft>
               <a:buClr>
                 <a:srgbClr val="FFFFFF"/>
@@ -12540,7 +13208,7 @@
               <a:defRPr/>
             </a:pPr>
             <a:r>
-              <a:rPr lang="en-US" sz="1800" b="1" i="0" u="none" strike="noStrike" cap="none" spc="0">
+              <a:rPr lang="en-US" sz="2400" b="1" i="0" u="none" strike="noStrike" cap="none" spc="0">
                 <a:solidFill>
                   <a:schemeClr val="lt1"/>
                 </a:solidFill>
@@ -12551,7 +13219,7 @@
               <a:t>Purpose: </a:t>
             </a:r>
             <a:r>
-              <a:rPr lang="en-US" sz="1800" b="0" i="0" u="none" strike="noStrike" cap="none" spc="0">
+              <a:rPr lang="en-US" sz="2400" b="0" i="0" u="none" strike="noStrike" cap="none" spc="0">
                 <a:solidFill>
                   <a:schemeClr val="lt1"/>
                 </a:solidFill>
@@ -12559,9 +13227,9 @@
                 <a:ea typeface="Times New Roman"/>
                 <a:cs typeface="Times New Roman"/>
               </a:rPr>
-              <a:t>Demonstrates basic authentication and secure handling of session credentials across the LAN.</a:t>
-            </a:r>
-            <a:endParaRPr sz="1800" b="0" u="none" strike="noStrike">
+              <a:t>Demonstrates secure authentication and credential handling across the LAN.</a:t>
+            </a:r>
+            <a:endParaRPr sz="2600" b="0" u="none" strike="noStrike">
               <a:solidFill>
                 <a:schemeClr val="lt1"/>
               </a:solidFill>
@@ -12575,7 +13243,7 @@
                 <a:spcPct val="100000"/>
               </a:lnSpc>
               <a:spcAft>
-                <a:spcPts val="1000"/>
+                <a:spcPts val="999"/>
               </a:spcAft>
               <a:buClr>
                 <a:srgbClr val="FFFFFF"/>
@@ -12585,7 +13253,7 @@
               <a:defRPr/>
             </a:pPr>
             <a:r>
-              <a:rPr lang="en-US" sz="2400" b="1" i="0" u="none" strike="noStrike" cap="none" spc="0">
+              <a:rPr lang="en-US" sz="2600" b="1" i="0" u="none" strike="noStrike" cap="none" spc="0">
                 <a:solidFill>
                   <a:schemeClr val="lt1"/>
                 </a:solidFill>
@@ -12595,7 +13263,7 @@
               </a:rPr>
               <a:t>Python Functions &amp; Logic:</a:t>
             </a:r>
-            <a:endParaRPr sz="2400" b="1" u="none" strike="noStrike">
+            <a:endParaRPr sz="2600" b="1" u="none" strike="noStrike">
               <a:solidFill>
                 <a:schemeClr val="lt1"/>
               </a:solidFill>
@@ -12609,7 +13277,7 @@
                 <a:spcPct val="100000"/>
               </a:lnSpc>
               <a:spcAft>
-                <a:spcPts val="1000"/>
+                <a:spcPts val="999"/>
               </a:spcAft>
               <a:buClr>
                 <a:srgbClr val="FFFFFF"/>
@@ -12619,7 +13287,7 @@
               <a:defRPr/>
             </a:pPr>
             <a:r>
-              <a:rPr lang="en-US" sz="2400" b="1" i="0" u="none" strike="noStrike" cap="none" spc="0">
+              <a:rPr lang="en-US" sz="2600" b="1" i="0" u="none" strike="noStrike" cap="none" spc="0">
                 <a:solidFill>
                   <a:schemeClr val="lt1"/>
                 </a:solidFill>
@@ -12630,7 +13298,7 @@
               <a:t>SHA-256 Hashing (hashlib.sha256()): </a:t>
             </a:r>
             <a:r>
-              <a:rPr lang="en-US" sz="2400" b="0" i="0" u="none" strike="noStrike" cap="none" spc="0">
+              <a:rPr lang="en-US" sz="2600" b="0" i="0" u="none" strike="noStrike" cap="none" spc="0">
                 <a:solidFill>
                   <a:schemeClr val="lt1"/>
                 </a:solidFill>
@@ -12640,7 +13308,7 @@
               </a:rPr>
               <a:t>Converts session passwords into fixed-length cryptographic hashes before transmission.</a:t>
             </a:r>
-            <a:endParaRPr sz="2400" b="1" i="0" u="none" strike="noStrike" cap="none" spc="0">
+            <a:endParaRPr sz="2600" b="1" i="0" u="none" strike="noStrike" cap="none" spc="0">
               <a:solidFill>
                 <a:schemeClr val="lt1"/>
               </a:solidFill>
@@ -12655,7 +13323,7 @@
                 <a:spcPct val="100000"/>
               </a:lnSpc>
               <a:spcAft>
-                <a:spcPts val="1000"/>
+                <a:spcPts val="999"/>
               </a:spcAft>
               <a:buClr>
                 <a:srgbClr val="FFFFFF"/>
@@ -12665,7 +13333,7 @@
               <a:defRPr/>
             </a:pPr>
             <a:r>
-              <a:rPr lang="en-US" sz="2400" b="1" i="0" u="none" strike="noStrike" cap="none" spc="0">
+              <a:rPr lang="en-US" sz="2600" b="1" i="0" u="none" strike="noStrike" cap="none" spc="0">
                 <a:solidFill>
                   <a:schemeClr val="lt1"/>
                 </a:solidFill>
@@ -12676,7 +13344,7 @@
               <a:t>Client Authentication:</a:t>
             </a:r>
             <a:r>
-              <a:rPr lang="en-US" sz="2400" b="0" i="0" u="none" strike="noStrike" cap="none" spc="0">
+              <a:rPr lang="en-US" sz="2600" b="0" i="0" u="none" strike="noStrike" cap="none" spc="0">
                 <a:solidFill>
                   <a:schemeClr val="lt1"/>
                 </a:solidFill>
@@ -12687,7 +13355,7 @@
               <a:t> </a:t>
             </a:r>
             <a:r>
-              <a:rPr lang="en-US" sz="2400" b="0" i="0" u="none" strike="noStrike" cap="none" spc="0">
+              <a:rPr lang="en-US" sz="2600" b="0" i="0" u="none" strike="noStrike" cap="none" spc="0">
                 <a:solidFill>
                   <a:schemeClr val="lt1"/>
                 </a:solidFill>
@@ -12697,7 +13365,7 @@
               </a:rPr>
               <a:t>Players must enter the correct session password before joining the host server.</a:t>
             </a:r>
-            <a:endParaRPr sz="2400" b="0" i="0" u="none" strike="noStrike" cap="none" spc="0">
+            <a:endParaRPr sz="2600" b="0" i="0" u="none" strike="noStrike" cap="none" spc="0">
               <a:solidFill>
                 <a:schemeClr val="lt1"/>
               </a:solidFill>
@@ -12712,7 +13380,7 @@
                 <a:spcPct val="100000"/>
               </a:lnSpc>
               <a:spcAft>
-                <a:spcPts val="1000"/>
+                <a:spcPts val="999"/>
               </a:spcAft>
               <a:buClr>
                 <a:srgbClr val="FFFFFF"/>
@@ -12722,7 +13390,7 @@
               <a:defRPr/>
             </a:pPr>
             <a:r>
-              <a:rPr lang="en-US" sz="2400" b="1" i="0" u="none" strike="noStrike" cap="none" spc="0">
+              <a:rPr lang="en-US" sz="2600" b="1" i="0" u="none" strike="noStrike" cap="none" spc="0">
                 <a:solidFill>
                   <a:schemeClr val="lt1"/>
                 </a:solidFill>
@@ -12733,7 +13401,7 @@
               <a:t>Secure Credential Handling: </a:t>
             </a:r>
             <a:r>
-              <a:rPr lang="en-US" sz="2400" b="0" i="0" u="none" strike="noStrike" cap="none" spc="0">
+              <a:rPr lang="en-US" sz="2600" b="0" i="0" u="none" strike="noStrike" cap="none" spc="0">
                 <a:solidFill>
                   <a:schemeClr val="lt1"/>
                 </a:solidFill>
@@ -12741,9 +13409,9 @@
                 <a:ea typeface="Times New Roman"/>
                 <a:cs typeface="Times New Roman"/>
               </a:rPr>
-              <a:t>Plain-text passwords are never transmitted across the network.</a:t>
-            </a:r>
-            <a:endParaRPr sz="2400" b="0" i="0" u="none" strike="noStrike" cap="none" spc="0">
+              <a:t>Plain-text passwords are never transmitted or stored directly by the application.</a:t>
+            </a:r>
+            <a:endParaRPr sz="2600" b="0" i="0" u="none" strike="noStrike" cap="none" spc="0">
               <a:solidFill>
                 <a:schemeClr val="lt1"/>
               </a:solidFill>
@@ -12758,7 +13426,7 @@
                 <a:spcPct val="100000"/>
               </a:lnSpc>
               <a:spcAft>
-                <a:spcPts val="1000"/>
+                <a:spcPts val="999"/>
               </a:spcAft>
               <a:buClr>
                 <a:srgbClr val="FFFFFF"/>
@@ -12768,7 +13436,7 @@
               <a:defRPr/>
             </a:pPr>
             <a:r>
-              <a:rPr lang="en-US" sz="2400" b="1" i="0" u="none" strike="noStrike" cap="none" spc="0">
+              <a:rPr lang="en-US" sz="2600" b="1" i="0" u="none" strike="noStrike" cap="none" spc="0">
                 <a:solidFill>
                   <a:schemeClr val="lt1"/>
                 </a:solidFill>
@@ -12779,7 +13447,7 @@
               <a:t>Replay Resistance: </a:t>
             </a:r>
             <a:r>
-              <a:rPr lang="en-US" sz="2400" b="0" i="0" u="none" strike="noStrike" cap="none" spc="0">
+              <a:rPr lang="en-US" sz="2600" b="0" i="0" u="none" strike="noStrike" cap="none" spc="0">
                 <a:solidFill>
                   <a:schemeClr val="lt1"/>
                 </a:solidFill>
@@ -12790,52 +13458,6 @@
               <a:t>Entering a previously intercepted hash directly will fail because the client hashes all input before transmission.</a:t>
             </a:r>
             <a:endParaRPr sz="2400" b="0" i="0" u="none" strike="noStrike" cap="none" spc="0">
-              <a:solidFill>
-                <a:schemeClr val="lt1"/>
-              </a:solidFill>
-              <a:latin typeface="Times New Roman"/>
-              <a:ea typeface="Times New Roman"/>
-              <a:cs typeface="Times New Roman"/>
-            </a:endParaRPr>
-          </a:p>
-          <a:p>
-            <a:pPr marL="285840" lvl="0" indent="-285840" algn="l" defTabSz="457200">
-              <a:lnSpc>
-                <a:spcPct val="100000"/>
-              </a:lnSpc>
-              <a:spcAft>
-                <a:spcPts val="1000"/>
-              </a:spcAft>
-              <a:buClr>
-                <a:srgbClr val="FFFFFF"/>
-              </a:buClr>
-              <a:buFont typeface="Arial"/>
-              <a:buChar char="•"/>
-              <a:defRPr/>
-            </a:pPr>
-            <a:r>
-              <a:rPr lang="en-US" sz="2400" b="1" i="0" u="none" strike="noStrike" cap="none" spc="0">
-                <a:solidFill>
-                  <a:schemeClr val="lt1"/>
-                </a:solidFill>
-                <a:latin typeface="Times New Roman"/>
-                <a:ea typeface="Times New Roman"/>
-                <a:cs typeface="Times New Roman"/>
-              </a:rPr>
-              <a:t>Defensive Networking: </a:t>
-            </a:r>
-            <a:r>
-              <a:rPr lang="en-US" sz="2400" b="0" i="0" u="none" strike="noStrike" cap="none" spc="0">
-                <a:solidFill>
-                  <a:schemeClr val="lt1"/>
-                </a:solidFill>
-                <a:latin typeface="Times New Roman"/>
-                <a:ea typeface="Times New Roman"/>
-                <a:cs typeface="Times New Roman"/>
-              </a:rPr>
-              <a:t>Invalid join requests are rejected safely without crashing the server.</a:t>
-            </a:r>
-            <a:endParaRPr sz="1800" b="0" i="0" u="none" strike="noStrike" cap="none" spc="0">
               <a:solidFill>
                 <a:schemeClr val="lt1"/>
               </a:solidFill>
@@ -12881,7 +13503,7 @@
       </p:grpSpPr>
       <p:sp>
         <p:nvSpPr>
-          <p:cNvPr id="1141943670" name="PlaceHolder 1"/>
+          <p:cNvPr id="1489438256" name="PlaceHolder 1"/>
           <p:cNvSpPr>
             <a:spLocks noGrp="1"/>
           </p:cNvSpPr>
@@ -12891,8 +13513,8 @@
         </p:nvSpPr>
         <p:spPr bwMode="auto">
           <a:xfrm>
-            <a:off x="917640" y="0"/>
-            <a:ext cx="10130760" cy="1455480"/>
+            <a:off x="975240" y="0"/>
+            <a:ext cx="10005840" cy="1379520"/>
           </a:xfrm>
           <a:prstGeom prst="rect">
             <a:avLst/>
@@ -12903,7 +13525,7 @@
           </a:ln>
         </p:spPr>
         <p:txBody>
-          <a:bodyPr lIns="91440" tIns="45720" rIns="91440" bIns="45720" anchor="ctr">
+          <a:bodyPr vertOverflow="overflow" horzOverflow="overflow" vert="horz" wrap="square" lIns="91440" tIns="45720" rIns="91440" bIns="45720" numCol="1" spcCol="0" rtlCol="0" fromWordArt="0" anchor="ctr" anchorCtr="0" forceAA="0" upright="0" compatLnSpc="0">
             <a:normAutofit/>
           </a:bodyPr>
           <a:p>
@@ -12918,14 +13540,15 @@
               <a:defRPr/>
             </a:pPr>
             <a:r>
-              <a:rPr lang="en-US" sz="5400" b="1" u="none" strike="noStrike" cap="all">
+              <a:rPr lang="en-US" sz="5400" b="1" i="0" u="none" strike="noStrike" cap="all" spc="0">
                 <a:solidFill>
                   <a:schemeClr val="lt1"/>
                 </a:solidFill>
                 <a:latin typeface="Times New Roman"/>
-                <a:ea typeface="Arial"/>
-              </a:rPr>
-              <a:t>Game 1: Heads or Tails</a:t>
+                <a:ea typeface="Times New Roman"/>
+                <a:cs typeface="Times New Roman"/>
+              </a:rPr>
+              <a:t>Network Defense</a:t>
             </a:r>
             <a:endParaRPr lang="en-US" sz="5400" b="0" u="none" strike="noStrike" cap="all">
               <a:solidFill>
@@ -12938,7 +13561,7 @@
       </p:sp>
       <p:sp>
         <p:nvSpPr>
-          <p:cNvPr id="318782491" name="PlaceHolder 2"/>
+          <p:cNvPr id="398853038" name="PlaceHolder 2"/>
           <p:cNvSpPr>
             <a:spLocks noGrp="1"/>
           </p:cNvSpPr>
@@ -12947,9 +13570,9 @@
           </p:nvPr>
         </p:nvSpPr>
         <p:spPr bwMode="auto">
-          <a:xfrm>
-            <a:off x="293400" y="1227600"/>
-            <a:ext cx="6325200" cy="5322600"/>
+          <a:xfrm rot="0" flipH="0" flipV="0">
+            <a:off x="649222" y="1052284"/>
+            <a:ext cx="10709280" cy="5361212"/>
           </a:xfrm>
           <a:prstGeom prst="rect">
             <a:avLst/>
@@ -12960,16 +13583,95 @@
           </a:ln>
         </p:spPr>
         <p:txBody>
-          <a:bodyPr lIns="91440" tIns="45720" rIns="91440" bIns="45720" anchor="ctr">
-            <a:normAutofit/>
+          <a:bodyPr vertOverflow="overflow" horzOverflow="overflow" vert="horz" wrap="square" lIns="91440" tIns="45720" rIns="91440" bIns="45720" numCol="1" spcCol="0" rtlCol="0" fromWordArt="0" anchor="ctr" anchorCtr="0" forceAA="0" upright="0" compatLnSpc="0">
+            <a:noAutofit/>
           </a:bodyPr>
           <a:p>
+            <a:pPr marL="0" indent="0" algn="l" defTabSz="457200">
+              <a:lnSpc>
+                <a:spcPct val="100000"/>
+              </a:lnSpc>
+              <a:spcAft>
+                <a:spcPts val="999"/>
+              </a:spcAft>
+              <a:buClr>
+                <a:srgbClr val="FFFFFF"/>
+              </a:buClr>
+              <a:buFont typeface="Arial"/>
+              <a:buNone/>
+              <a:defRPr/>
+            </a:pPr>
+            <a:r>
+              <a:rPr lang="en-US" sz="1800" b="1" i="0" u="none" strike="noStrike" cap="none" spc="0">
+                <a:solidFill>
+                  <a:schemeClr val="lt1"/>
+                </a:solidFill>
+                <a:latin typeface="Times New Roman"/>
+                <a:ea typeface="Times New Roman"/>
+                <a:cs typeface="Times New Roman"/>
+              </a:rPr>
+              <a:t>Purpose: </a:t>
+            </a:r>
+            <a:r>
+              <a:rPr lang="en-US" sz="1800" b="0" i="0" u="none" strike="noStrike" cap="none" spc="0">
+                <a:solidFill>
+                  <a:schemeClr val="lt1"/>
+                </a:solidFill>
+                <a:latin typeface="Times New Roman"/>
+                <a:ea typeface="Times New Roman"/>
+                <a:cs typeface="Times New Roman"/>
+              </a:rPr>
+              <a:t>Demonstrates defensive networking protections and security monitoring features.</a:t>
+            </a:r>
+            <a:endParaRPr sz="1800" b="0" u="none" strike="noStrike">
+              <a:solidFill>
+                <a:schemeClr val="lt1"/>
+              </a:solidFill>
+              <a:latin typeface="Times New Roman"/>
+              <a:ea typeface="Arial"/>
+            </a:endParaRPr>
+          </a:p>
+          <a:p>
+            <a:pPr marL="0" indent="0" algn="l" defTabSz="457200">
+              <a:lnSpc>
+                <a:spcPct val="100000"/>
+              </a:lnSpc>
+              <a:spcAft>
+                <a:spcPts val="999"/>
+              </a:spcAft>
+              <a:buClr>
+                <a:srgbClr val="FFFFFF"/>
+              </a:buClr>
+              <a:buFont typeface="Arial"/>
+              <a:buNone/>
+              <a:defRPr/>
+            </a:pPr>
+            <a:r>
+              <a:rPr lang="en-US" sz="2200" b="1" i="0" u="none" strike="noStrike" cap="none" spc="0">
+                <a:solidFill>
+                  <a:schemeClr val="lt1"/>
+                </a:solidFill>
+                <a:latin typeface="Times New Roman"/>
+                <a:ea typeface="Times New Roman"/>
+                <a:cs typeface="Times New Roman"/>
+              </a:rPr>
+              <a:t>Python Functions &amp; Logic:</a:t>
+            </a:r>
+            <a:endParaRPr sz="2200" b="1" u="none" strike="noStrike">
+              <a:solidFill>
+                <a:schemeClr val="lt1"/>
+              </a:solidFill>
+              <a:latin typeface="Times New Roman"/>
+              <a:ea typeface="Arial"/>
+            </a:endParaRPr>
+          </a:p>
+          <a:p>
             <a:pPr marL="285840" indent="-285840" algn="l" defTabSz="457200">
               <a:lnSpc>
                 <a:spcPct val="100000"/>
               </a:lnSpc>
               <a:spcAft>
-                <a:spcPts val="1001"/>
+                <a:spcPts val="999"/>
               </a:spcAft>
               <a:buClr>
                 <a:srgbClr val="FFFFFF"/>
@@ -12979,30 +13681,34 @@
               <a:defRPr/>
             </a:pPr>
             <a:r>
-              <a:rPr lang="en-US" sz="2400" b="1" u="none" strike="noStrike">
+              <a:rPr lang="en-US" sz="2200" b="1" i="0" u="none" strike="noStrike" cap="none" spc="0">
                 <a:solidFill>
                   <a:schemeClr val="lt1"/>
                 </a:solidFill>
                 <a:latin typeface="Times New Roman"/>
-                <a:ea typeface="Arial"/>
-              </a:rPr>
-              <a:t>Purpose:</a:t>
-            </a:r>
-            <a:r>
-              <a:rPr lang="en-US" sz="2400" b="0" u="none" strike="noStrike">
+                <a:ea typeface="Times New Roman"/>
+                <a:cs typeface="Times New Roman"/>
+              </a:rPr>
+              <a:t>IP-Based Rate Limiting</a:t>
+            </a:r>
+            <a:r>
+              <a:rPr lang="en-US" sz="2200" b="0" i="0" u="none" strike="noStrike" cap="none" spc="0">
                 <a:solidFill>
                   <a:schemeClr val="lt1"/>
                 </a:solidFill>
                 <a:latin typeface="Times New Roman"/>
-                <a:ea typeface="Arial"/>
-              </a:rPr>
-              <a:t> A quick-fire test of the network's ability to handle rapid-response binary choices and synchronized resolution.</a:t>
-            </a:r>
-            <a:endParaRPr lang="en-US" sz="2400" b="0" u="none" strike="noStrike">
+                <a:ea typeface="Times New Roman"/>
+                <a:cs typeface="Times New Roman"/>
+              </a:rPr>
+              <a:t>: Repeated failed authentication attempts permanently block the offending IP address for the remainder of the host session.</a:t>
+            </a:r>
+            <a:endParaRPr sz="2200" b="1" i="0" u="none" strike="noStrike" cap="none" spc="0">
               <a:solidFill>
                 <a:schemeClr val="lt1"/>
               </a:solidFill>
-              <a:latin typeface="Calibri"/>
+              <a:latin typeface="Times New Roman"/>
+              <a:ea typeface="Times New Roman"/>
+              <a:cs typeface="Times New Roman"/>
             </a:endParaRPr>
           </a:p>
           <a:p>
@@ -13011,7 +13717,7 @@
                 <a:spcPct val="100000"/>
               </a:lnSpc>
               <a:spcAft>
-                <a:spcPts val="1001"/>
+                <a:spcPts val="999"/>
               </a:spcAft>
               <a:buClr>
                 <a:srgbClr val="FFFFFF"/>
@@ -13021,29 +13727,43 @@
               <a:defRPr/>
             </a:pPr>
             <a:r>
-              <a:rPr lang="en-US" sz="2400" b="1" u="none" strike="noStrike">
+              <a:rPr lang="en-US" sz="2200" b="1" i="0" u="none" strike="noStrike" cap="none" spc="0">
                 <a:solidFill>
                   <a:schemeClr val="lt1"/>
                 </a:solidFill>
                 <a:latin typeface="Times New Roman"/>
-                <a:ea typeface="Arial"/>
-              </a:rPr>
-              <a:t>Python Functions &amp; Logic:</a:t>
-            </a:r>
-            <a:endParaRPr lang="en-US" sz="2400" b="0" u="none" strike="noStrike">
+                <a:ea typeface="Times New Roman"/>
+                <a:cs typeface="Times New Roman"/>
+              </a:rPr>
+              <a:t>Over-sized Packet Protection: </a:t>
+            </a:r>
+            <a:r>
+              <a:rPr lang="en-US" sz="2200" b="0" i="0" u="none" strike="noStrike" cap="none" spc="0">
+                <a:solidFill>
+                  <a:schemeClr val="lt1"/>
+                </a:solidFill>
+                <a:latin typeface="Times New Roman"/>
+                <a:ea typeface="Times New Roman"/>
+                <a:cs typeface="Times New Roman"/>
+              </a:rPr>
+              <a:t>Incoming messages exceeding the maximum allowed packet size are rejected safely to reduce denial-of-service and memory abuse risks.</a:t>
+            </a:r>
+            <a:endParaRPr sz="2200" b="0" i="0" u="none" strike="noStrike" cap="none" spc="0">
               <a:solidFill>
                 <a:schemeClr val="lt1"/>
               </a:solidFill>
-              <a:latin typeface="Calibri"/>
-            </a:endParaRPr>
-          </a:p>
-          <a:p>
-            <a:pPr marL="285840" indent="-285840" algn="l" defTabSz="457200">
-              <a:lnSpc>
-                <a:spcPct val="100000"/>
-              </a:lnSpc>
-              <a:spcAft>
-                <a:spcPts val="1001"/>
+              <a:latin typeface="Times New Roman"/>
+              <a:ea typeface="Times New Roman"/>
+              <a:cs typeface="Times New Roman"/>
+            </a:endParaRPr>
+          </a:p>
+          <a:p>
+            <a:pPr marL="285840" lvl="0" indent="-285840" algn="l" defTabSz="457200">
+              <a:lnSpc>
+                <a:spcPct val="100000"/>
+              </a:lnSpc>
+              <a:spcAft>
+                <a:spcPts val="999"/>
               </a:spcAft>
               <a:buClr>
                 <a:srgbClr val="FFFFFF"/>
@@ -13053,29 +13773,43 @@
               <a:defRPr/>
             </a:pPr>
             <a:r>
-              <a:rPr lang="en-US" sz="2400" b="0" u="none" strike="noStrike">
+              <a:rPr lang="en-US" sz="2200" b="1" i="0" u="none" strike="noStrike" cap="none" spc="0">
                 <a:solidFill>
                   <a:schemeClr val="lt1"/>
                 </a:solidFill>
                 <a:latin typeface="Times New Roman"/>
-                <a:ea typeface="Arial"/>
-              </a:rPr>
-              <a:t>random.choice(['Heads', 'Tails']): Used by the server to determine the winning outcome.</a:t>
-            </a:r>
-            <a:endParaRPr lang="en-US" sz="2400" b="0" u="none" strike="noStrike">
+                <a:ea typeface="Times New Roman"/>
+                <a:cs typeface="Times New Roman"/>
+              </a:rPr>
+              <a:t>Security Event Logging: </a:t>
+            </a:r>
+            <a:r>
+              <a:rPr lang="en-US" sz="2200" b="0" i="0" u="none" strike="noStrike" cap="none" spc="0">
+                <a:solidFill>
+                  <a:schemeClr val="lt1"/>
+                </a:solidFill>
+                <a:latin typeface="Times New Roman"/>
+                <a:ea typeface="Times New Roman"/>
+                <a:cs typeface="Times New Roman"/>
+              </a:rPr>
+              <a:t>Successful joins, failed login attempts, rate-limit triggers, and disconnect events are persistently written to security.log.</a:t>
+            </a:r>
+            <a:endParaRPr sz="2200" b="0" i="0" u="none" strike="noStrike" cap="none" spc="0">
               <a:solidFill>
                 <a:schemeClr val="lt1"/>
               </a:solidFill>
-              <a:latin typeface="Calibri"/>
-            </a:endParaRPr>
-          </a:p>
-          <a:p>
-            <a:pPr marL="285840" indent="-285840" algn="l" defTabSz="457200">
-              <a:lnSpc>
-                <a:spcPct val="100000"/>
-              </a:lnSpc>
-              <a:spcAft>
-                <a:spcPts val="1001"/>
+              <a:latin typeface="Times New Roman"/>
+              <a:ea typeface="Times New Roman"/>
+              <a:cs typeface="Times New Roman"/>
+            </a:endParaRPr>
+          </a:p>
+          <a:p>
+            <a:pPr marL="285840" lvl="0" indent="-285840" algn="l" defTabSz="457200">
+              <a:lnSpc>
+                <a:spcPct val="100000"/>
+              </a:lnSpc>
+              <a:spcAft>
+                <a:spcPts val="999"/>
               </a:spcAft>
               <a:buClr>
                 <a:srgbClr val="FFFFFF"/>
@@ -13085,29 +13819,43 @@
               <a:defRPr/>
             </a:pPr>
             <a:r>
-              <a:rPr lang="en-US" sz="2400" b="0" u="none" strike="noStrike">
+              <a:rPr lang="en-US" sz="2200" b="1" i="0" u="none" strike="noStrike" cap="none" spc="0">
                 <a:solidFill>
                   <a:schemeClr val="lt1"/>
                 </a:solidFill>
                 <a:latin typeface="Times New Roman"/>
-                <a:ea typeface="Arial"/>
-              </a:rPr>
-              <a:t>input().strip().upper(): Captures the player's choice and cleans the data before sending.</a:t>
-            </a:r>
-            <a:endParaRPr lang="en-US" sz="2400" b="0" u="none" strike="noStrike">
+                <a:ea typeface="Times New Roman"/>
+                <a:cs typeface="Times New Roman"/>
+              </a:rPr>
+              <a:t>Defensive Socket Handling: </a:t>
+            </a:r>
+            <a:r>
+              <a:rPr lang="en-US" sz="2200" b="0" i="0" u="none" strike="noStrike" cap="none" spc="0">
+                <a:solidFill>
+                  <a:schemeClr val="lt1"/>
+                </a:solidFill>
+                <a:latin typeface="Times New Roman"/>
+                <a:ea typeface="Times New Roman"/>
+                <a:cs typeface="Times New Roman"/>
+              </a:rPr>
+              <a:t>Invalid join requests and malformed packets are rejected without crashing the server.</a:t>
+            </a:r>
+            <a:endParaRPr sz="2200" b="0" i="0" u="none" strike="noStrike" cap="none" spc="0">
               <a:solidFill>
                 <a:schemeClr val="lt1"/>
               </a:solidFill>
-              <a:latin typeface="Calibri"/>
-            </a:endParaRPr>
-          </a:p>
-          <a:p>
-            <a:pPr marL="285840" indent="-285840" algn="l" defTabSz="457200">
-              <a:lnSpc>
-                <a:spcPct val="100000"/>
-              </a:lnSpc>
-              <a:spcAft>
-                <a:spcPts val="1001"/>
+              <a:latin typeface="Times New Roman"/>
+              <a:ea typeface="Times New Roman"/>
+              <a:cs typeface="Times New Roman"/>
+            </a:endParaRPr>
+          </a:p>
+          <a:p>
+            <a:pPr marL="285840" lvl="0" indent="-285840" algn="l" defTabSz="457200">
+              <a:lnSpc>
+                <a:spcPct val="100000"/>
+              </a:lnSpc>
+              <a:spcAft>
+                <a:spcPts val="999"/>
               </a:spcAft>
               <a:buClr>
                 <a:srgbClr val="FFFFFF"/>
@@ -13117,48 +13865,38 @@
               <a:defRPr/>
             </a:pPr>
             <a:r>
-              <a:rPr lang="en-US" sz="2400" b="0" u="none" strike="noStrike">
+              <a:rPr lang="en-US" sz="2200" b="1" i="0" u="none" strike="noStrike" cap="none" spc="0">
                 <a:solidFill>
                   <a:schemeClr val="lt1"/>
                 </a:solidFill>
                 <a:latin typeface="Times New Roman"/>
-                <a:ea typeface="Arial"/>
-              </a:rPr>
-              <a:t>send_data() / recv_data(): Custom wrapper functions for socket.send() and socket.recv() to exchange JSON packets between the Pi and the Host.</a:t>
-            </a:r>
-            <a:endParaRPr lang="en-US" sz="2400" b="0" u="none" strike="noStrike">
+                <a:ea typeface="Times New Roman"/>
+                <a:cs typeface="Times New Roman"/>
+              </a:rPr>
+              <a:t>Remaining Security Limitation: </a:t>
+            </a:r>
+            <a:r>
+              <a:rPr lang="en-US" sz="2200" b="0" i="0" u="none" strike="noStrike" cap="none" spc="0">
+                <a:solidFill>
+                  <a:schemeClr val="lt1"/>
+                </a:solidFill>
+                <a:latin typeface="Times New Roman"/>
+                <a:ea typeface="Times New Roman"/>
+                <a:cs typeface="Times New Roman"/>
+              </a:rPr>
+              <a:t>Replay-style attacks may still be possible if an attacker modifies the Python client or crafts custom packets using intercepted hash values.</a:t>
+            </a:r>
+            <a:endParaRPr sz="1800" b="0" i="0" u="none" strike="noStrike" cap="none" spc="0">
               <a:solidFill>
                 <a:schemeClr val="lt1"/>
               </a:solidFill>
-              <a:latin typeface="Calibri"/>
+              <a:latin typeface="Times New Roman"/>
+              <a:ea typeface="Times New Roman"/>
+              <a:cs typeface="Times New Roman"/>
             </a:endParaRPr>
           </a:p>
         </p:txBody>
       </p:sp>
-      <p:pic>
-        <p:nvPicPr>
-          <p:cNvPr id="166114950" name="Picture 4" descr="A screenshot of a computer screen&#10;&#10;Description automatically generated"/>
-          <p:cNvPicPr/>
-          <p:nvPr/>
-        </p:nvPicPr>
-        <p:blipFill rotWithShape="1">
-          <a:blip r:embed="rId3"/>
-          <a:stretch/>
-        </p:blipFill>
-        <p:spPr bwMode="auto">
-          <a:xfrm>
-            <a:off x="6619320" y="2038320"/>
-            <a:ext cx="5278680" cy="3418920"/>
-          </a:xfrm>
-          <a:prstGeom prst="rect">
-            <a:avLst/>
-          </a:prstGeom>
-          <a:noFill/>
-          <a:ln w="0">
-            <a:noFill/>
-          </a:ln>
-        </p:spPr>
-      </p:pic>
     </p:spTree>
   </p:cSld>
   <p:clrMapOvr>
@@ -13194,7 +13932,7 @@
       </p:grpSpPr>
       <p:sp>
         <p:nvSpPr>
-          <p:cNvPr id="1901704429" name="PlaceHolder 1"/>
+          <p:cNvPr id="349462746" name="PlaceHolder 1"/>
           <p:cNvSpPr>
             <a:spLocks noGrp="1"/>
           </p:cNvSpPr>
@@ -13204,8 +13942,8 @@
         </p:nvSpPr>
         <p:spPr bwMode="auto">
           <a:xfrm>
-            <a:off x="125640" y="-214200"/>
-            <a:ext cx="11772000" cy="1455480"/>
+            <a:off x="917640" y="0"/>
+            <a:ext cx="10130760" cy="1455480"/>
           </a:xfrm>
           <a:prstGeom prst="rect">
             <a:avLst/>
@@ -13217,7 +13955,7 @@
         </p:spPr>
         <p:txBody>
           <a:bodyPr lIns="91440" tIns="45720" rIns="91440" bIns="45720" anchor="ctr">
-            <a:noAutofit/>
+            <a:normAutofit/>
           </a:bodyPr>
           <a:p>
             <a:pPr indent="0" algn="ctr" defTabSz="457200">
@@ -13238,7 +13976,7 @@
                 <a:latin typeface="Times New Roman"/>
                 <a:ea typeface="Arial"/>
               </a:rPr>
-              <a:t>Game 2: Rock, Paper, Scissors</a:t>
+              <a:t>Game 1: Heads or Tails</a:t>
             </a:r>
             <a:endParaRPr lang="en-US" sz="5400" b="0" u="none" strike="noStrike" cap="all">
               <a:solidFill>
@@ -13251,7 +13989,7 @@
       </p:sp>
       <p:sp>
         <p:nvSpPr>
-          <p:cNvPr id="486262032" name="PlaceHolder 2"/>
+          <p:cNvPr id="253150462" name="PlaceHolder 2"/>
           <p:cNvSpPr>
             <a:spLocks noGrp="1"/>
           </p:cNvSpPr>
@@ -13260,9 +13998,9 @@
           </p:nvPr>
         </p:nvSpPr>
         <p:spPr bwMode="auto">
-          <a:xfrm flipH="0" flipV="0">
-            <a:off x="83522" y="1054445"/>
-            <a:ext cx="6548619" cy="5321880"/>
+          <a:xfrm>
+            <a:off x="293400" y="1227600"/>
+            <a:ext cx="6325200" cy="5322600"/>
           </a:xfrm>
           <a:prstGeom prst="rect">
             <a:avLst/>
@@ -13274,7 +14012,7 @@
         </p:spPr>
         <p:txBody>
           <a:bodyPr lIns="91440" tIns="45720" rIns="91440" bIns="45720" anchor="ctr">
-            <a:noAutofit/>
+            <a:normAutofit/>
           </a:bodyPr>
           <a:p>
             <a:pPr marL="285840" indent="-285840" algn="l" defTabSz="457200">
@@ -13309,7 +14047,7 @@
                 <a:latin typeface="Times New Roman"/>
                 <a:ea typeface="Arial"/>
               </a:rPr>
-              <a:t> Demonstrates server-side logic validation where the Host must compare multiple client inputs against a central "AI" move.</a:t>
+              <a:t> A quick-fire test of the network's ability to handle rapid-response binary choices and synchronized resolution.</a:t>
             </a:r>
             <a:endParaRPr lang="en-US" sz="2400" b="0" u="none" strike="noStrike">
               <a:solidFill>
@@ -13366,24 +14104,14 @@
               <a:defRPr/>
             </a:pPr>
             <a:r>
-              <a:rPr lang="en-US" sz="2400" b="1" u="none" strike="noStrike">
+              <a:rPr lang="en-US" sz="2400" b="0" u="none" strike="noStrike">
                 <a:solidFill>
                   <a:schemeClr val="lt1"/>
                 </a:solidFill>
                 <a:latin typeface="Times New Roman"/>
                 <a:ea typeface="Arial"/>
               </a:rPr>
-              <a:t>Logic Mapping:</a:t>
-            </a:r>
-            <a:r>
-              <a:rPr lang="en-US" sz="2400" b="0" u="none" strike="noStrike">
-                <a:solidFill>
-                  <a:schemeClr val="lt1"/>
-                </a:solidFill>
-                <a:latin typeface="Times New Roman"/>
-                <a:ea typeface="Arial"/>
-              </a:rPr>
-              <a:t> Uses a Dictionary or Nested if/elif statements to define win/loss/tie conditions (e.g., if user == 'R' and computer == 'S').</a:t>
+              <a:t>random.choice(['Heads', 'Tails']): Used by the server to determine the winning outcome.</a:t>
             </a:r>
             <a:endParaRPr lang="en-US" sz="2400" b="0" u="none" strike="noStrike">
               <a:solidFill>
@@ -13415,7 +14143,39 @@
                 <a:latin typeface="Times New Roman"/>
                 <a:ea typeface="Arial"/>
               </a:rPr>
-              <a:t>json.dumps(): Converts the player's move into a string format that can be transmitted over the TCP socket.</a:t>
+              <a:t>input().strip().upper(): Captures the player's choice and cleans the data before sending.</a:t>
+            </a:r>
+            <a:endParaRPr lang="en-US" sz="2400" b="0" u="none" strike="noStrike">
+              <a:solidFill>
+                <a:schemeClr val="lt1"/>
+              </a:solidFill>
+              <a:latin typeface="Calibri"/>
+            </a:endParaRPr>
+          </a:p>
+          <a:p>
+            <a:pPr marL="285840" indent="-285840" algn="l" defTabSz="457200">
+              <a:lnSpc>
+                <a:spcPct val="100000"/>
+              </a:lnSpc>
+              <a:spcAft>
+                <a:spcPts val="1001"/>
+              </a:spcAft>
+              <a:buClr>
+                <a:srgbClr val="FFFFFF"/>
+              </a:buClr>
+              <a:buFont typeface="Arial"/>
+              <a:buChar char="•"/>
+              <a:defRPr/>
+            </a:pPr>
+            <a:r>
+              <a:rPr lang="en-US" sz="2400" b="0" u="none" strike="noStrike">
+                <a:solidFill>
+                  <a:schemeClr val="lt1"/>
+                </a:solidFill>
+                <a:latin typeface="Times New Roman"/>
+                <a:ea typeface="Arial"/>
+              </a:rPr>
+              <a:t>send_data() / recv_data(): Custom wrapper functions for socket.send() and socket.recv() to exchange JSON packets between the Pi and the Host.</a:t>
             </a:r>
             <a:endParaRPr lang="en-US" sz="2400" b="0" u="none" strike="noStrike">
               <a:solidFill>
@@ -13428,7 +14188,7 @@
       </p:sp>
       <p:pic>
         <p:nvPicPr>
-          <p:cNvPr id="691416118" name="Picture 6" descr="A screen shot of a computer screen&#10;&#10;Description automatically generated"/>
+          <p:cNvPr id="1192381581" name="Picture 4" descr="A screenshot of a computer screen&#10;&#10;Description automatically generated"/>
           <p:cNvPicPr/>
           <p:nvPr/>
         </p:nvPicPr>
@@ -13438,8 +14198,8 @@
         </p:blipFill>
         <p:spPr bwMode="auto">
           <a:xfrm>
-            <a:off x="6603840" y="2338920"/>
-            <a:ext cx="5484240" cy="2705400"/>
+            <a:off x="6619320" y="2038320"/>
+            <a:ext cx="5278680" cy="3418920"/>
           </a:xfrm>
           <a:prstGeom prst="rect">
             <a:avLst/>
@@ -13485,7 +14245,7 @@
       </p:grpSpPr>
       <p:sp>
         <p:nvSpPr>
-          <p:cNvPr id="255332695" name="PlaceHolder 1"/>
+          <p:cNvPr id="1144762807" name="PlaceHolder 1"/>
           <p:cNvSpPr>
             <a:spLocks noGrp="1"/>
           </p:cNvSpPr>
@@ -13495,8 +14255,8 @@
         </p:nvSpPr>
         <p:spPr bwMode="auto">
           <a:xfrm>
-            <a:off x="-158400" y="-193320"/>
-            <a:ext cx="12349440" cy="1353240"/>
+            <a:off x="125640" y="-214200"/>
+            <a:ext cx="11772000" cy="1455480"/>
           </a:xfrm>
           <a:prstGeom prst="rect">
             <a:avLst/>
@@ -13529,7 +14289,7 @@
                 <a:latin typeface="Times New Roman"/>
                 <a:ea typeface="Arial"/>
               </a:rPr>
-              <a:t>Game 3: Number Guessing Game</a:t>
+              <a:t>Game 2: Rock, Paper, Scissors</a:t>
             </a:r>
             <a:endParaRPr lang="en-US" sz="5400" b="0" u="none" strike="noStrike" cap="all">
               <a:solidFill>
@@ -13542,7 +14302,7 @@
       </p:sp>
       <p:sp>
         <p:nvSpPr>
-          <p:cNvPr id="1283244704" name="PlaceHolder 2"/>
+          <p:cNvPr id="910376715" name="PlaceHolder 2"/>
           <p:cNvSpPr>
             <a:spLocks noGrp="1"/>
           </p:cNvSpPr>
@@ -13551,9 +14311,9 @@
           </p:nvPr>
         </p:nvSpPr>
         <p:spPr bwMode="auto">
-          <a:xfrm>
-            <a:off x="178920" y="1160640"/>
-            <a:ext cx="5837039" cy="5499360"/>
+          <a:xfrm flipH="0" flipV="0">
+            <a:off x="83522" y="1054445"/>
+            <a:ext cx="6548619" cy="5321880"/>
           </a:xfrm>
           <a:prstGeom prst="rect">
             <a:avLst/>
@@ -13565,7 +14325,7 @@
         </p:spPr>
         <p:txBody>
           <a:bodyPr lIns="91440" tIns="45720" rIns="91440" bIns="45720" anchor="ctr">
-            <a:normAutofit lnSpcReduction="9999"/>
+            <a:noAutofit/>
           </a:bodyPr>
           <a:p>
             <a:pPr marL="285840" indent="-285840" algn="l" defTabSz="457200">
@@ -13600,7 +14360,7 @@
                 <a:latin typeface="Times New Roman"/>
                 <a:ea typeface="Arial"/>
               </a:rPr>
-              <a:t> Showcases mathematical processing and "Shortest Distance" algorithms to determine a winner among multiple participants.</a:t>
+              <a:t> Demonstrates server-side logic validation where the Host must compare multiple client inputs against a central "AI" move.</a:t>
             </a:r>
             <a:endParaRPr lang="en-US" sz="2400" b="0" u="none" strike="noStrike">
               <a:solidFill>
@@ -13657,6 +14417,16 @@
               <a:defRPr/>
             </a:pPr>
             <a:r>
+              <a:rPr lang="en-US" sz="2400" b="1" u="none" strike="noStrike">
+                <a:solidFill>
+                  <a:schemeClr val="lt1"/>
+                </a:solidFill>
+                <a:latin typeface="Times New Roman"/>
+                <a:ea typeface="Arial"/>
+              </a:rPr>
+              <a:t>Logic Mapping:</a:t>
+            </a:r>
+            <a:r>
               <a:rPr lang="en-US" sz="2400" b="0" u="none" strike="noStrike">
                 <a:solidFill>
                   <a:schemeClr val="lt1"/>
@@ -13664,7 +14434,7 @@
                 <a:latin typeface="Times New Roman"/>
                 <a:ea typeface="Arial"/>
               </a:rPr>
-              <a:t>random.randint(1, 100): Generates the secret target number on the Host machine.</a:t>
+              <a:t> Uses a Dictionary or Nested if/elif statements to define win/loss/tie conditions (e.g., if user == 'R' and computer == 'S').</a:t>
             </a:r>
             <a:endParaRPr lang="en-US" sz="2400" b="0" u="none" strike="noStrike">
               <a:solidFill>
@@ -13696,82 +14466,9 @@
                 <a:latin typeface="Times New Roman"/>
                 <a:ea typeface="Arial"/>
               </a:rPr>
-              <a:t>abs(target - guess): The </a:t>
-            </a:r>
-            <a:r>
-              <a:rPr lang="en-US" sz="2400" b="1" u="none" strike="noStrike">
-                <a:solidFill>
-                  <a:schemeClr val="lt1"/>
-                </a:solidFill>
-                <a:latin typeface="Times New Roman"/>
-                <a:ea typeface="Arial"/>
-              </a:rPr>
-              <a:t>Absolute Value</a:t>
-            </a:r>
-            <a:r>
-              <a:rPr lang="en-US" sz="2400" b="0" u="none" strike="noStrike">
-                <a:solidFill>
-                  <a:schemeClr val="lt1"/>
-                </a:solidFill>
-                <a:latin typeface="Times New Roman"/>
-                <a:ea typeface="Arial"/>
-              </a:rPr>
-              <a:t> function calculates how far each player is from the target, regardless of whether they guessed too high or too low.</a:t>
+              <a:t>json.dumps(): Converts the player's move into a string format that can be transmitted over the TCP socket.</a:t>
             </a:r>
             <a:endParaRPr lang="en-US" sz="2400" b="0" u="none" strike="noStrike">
-              <a:solidFill>
-                <a:schemeClr val="lt1"/>
-              </a:solidFill>
-              <a:latin typeface="Calibri"/>
-            </a:endParaRPr>
-          </a:p>
-          <a:p>
-            <a:pPr marL="285840" indent="-285840" algn="l" defTabSz="457200">
-              <a:lnSpc>
-                <a:spcPct val="100000"/>
-              </a:lnSpc>
-              <a:spcAft>
-                <a:spcPts val="1001"/>
-              </a:spcAft>
-              <a:buClr>
-                <a:srgbClr val="FFFFFF"/>
-              </a:buClr>
-              <a:buFont typeface="Arial"/>
-              <a:buChar char="•"/>
-              <a:defRPr/>
-            </a:pPr>
-            <a:r>
-              <a:rPr lang="en-US" sz="2400" b="0" u="none" strike="noStrike">
-                <a:solidFill>
-                  <a:schemeClr val="lt1"/>
-                </a:solidFill>
-                <a:latin typeface="Times New Roman"/>
-                <a:ea typeface="Arial"/>
-              </a:rPr>
-              <a:t>min(): Applied to a list of player distances to identify the "closest" guess and declare the round winner.</a:t>
-            </a:r>
-            <a:endParaRPr lang="en-US" sz="2400" b="0" u="none" strike="noStrike">
-              <a:solidFill>
-                <a:schemeClr val="lt1"/>
-              </a:solidFill>
-              <a:latin typeface="Calibri"/>
-            </a:endParaRPr>
-          </a:p>
-          <a:p>
-            <a:pPr indent="0" algn="l" defTabSz="457200">
-              <a:lnSpc>
-                <a:spcPct val="100000"/>
-              </a:lnSpc>
-              <a:spcAft>
-                <a:spcPts val="1001"/>
-              </a:spcAft>
-              <a:buNone/>
-              <a:tabLst>
-                <a:tab pos="0" algn="l"/>
-              </a:tabLst>
-              <a:defRPr/>
-            </a:pPr>
-            <a:endParaRPr lang="en-US" sz="1800" b="0" u="none" strike="noStrike">
               <a:solidFill>
                 <a:schemeClr val="lt1"/>
               </a:solidFill>
@@ -13782,19 +14479,18 @@
       </p:sp>
       <p:pic>
         <p:nvPicPr>
-          <p:cNvPr id="270675864" name="Picture 4" descr="A purple and blue text&#10;&#10;Description automatically generated"/>
+          <p:cNvPr id="1490310995" name="Picture 6" descr="A screen shot of a computer screen&#10;&#10;Description automatically generated"/>
           <p:cNvPicPr/>
           <p:nvPr/>
         </p:nvPicPr>
         <p:blipFill rotWithShape="1">
           <a:blip r:embed="rId3"/>
-          <a:srcRect l="0" t="8172" r="0" b="5617"/>
           <a:stretch/>
         </p:blipFill>
         <p:spPr bwMode="auto">
           <a:xfrm>
-            <a:off x="5759640" y="2917440"/>
-            <a:ext cx="6338160" cy="1044000"/>
+            <a:off x="6603840" y="2338920"/>
+            <a:ext cx="5484240" cy="2705400"/>
           </a:xfrm>
           <a:prstGeom prst="rect">
             <a:avLst/>
@@ -13840,7 +14536,7 @@
       </p:grpSpPr>
       <p:sp>
         <p:nvSpPr>
-          <p:cNvPr id="1986550603" name="PlaceHolder 1"/>
+          <p:cNvPr id="441638481" name="PlaceHolder 1"/>
           <p:cNvSpPr>
             <a:spLocks noGrp="1"/>
           </p:cNvSpPr>
@@ -13850,8 +14546,8 @@
         </p:nvSpPr>
         <p:spPr bwMode="auto">
           <a:xfrm>
-            <a:off x="685800" y="-164160"/>
-            <a:ext cx="10130760" cy="1455480"/>
+            <a:off x="-158400" y="-193320"/>
+            <a:ext cx="12349440" cy="1353240"/>
           </a:xfrm>
           <a:prstGeom prst="rect">
             <a:avLst/>
@@ -13863,7 +14559,7 @@
         </p:spPr>
         <p:txBody>
           <a:bodyPr lIns="91440" tIns="45720" rIns="91440" bIns="45720" anchor="ctr">
-            <a:normAutofit/>
+            <a:noAutofit/>
           </a:bodyPr>
           <a:p>
             <a:pPr indent="0" algn="ctr" defTabSz="457200">
@@ -13884,7 +14580,7 @@
                 <a:latin typeface="Times New Roman"/>
                 <a:ea typeface="Arial"/>
               </a:rPr>
-              <a:t>GAME 4: Snake </a:t>
+              <a:t>Game 3: Number Guessing Game</a:t>
             </a:r>
             <a:endParaRPr lang="en-US" sz="5400" b="0" u="none" strike="noStrike" cap="all">
               <a:solidFill>
@@ -13897,7 +14593,7 @@
       </p:sp>
       <p:sp>
         <p:nvSpPr>
-          <p:cNvPr id="742517039" name="PlaceHolder 2"/>
+          <p:cNvPr id="1938227210" name="PlaceHolder 2"/>
           <p:cNvSpPr>
             <a:spLocks noGrp="1"/>
           </p:cNvSpPr>
@@ -13907,8 +14603,8 @@
         </p:nvSpPr>
         <p:spPr bwMode="auto">
           <a:xfrm>
-            <a:off x="114480" y="1103400"/>
-            <a:ext cx="6920640" cy="5753880"/>
+            <a:off x="178920" y="1160640"/>
+            <a:ext cx="5837039" cy="5499360"/>
           </a:xfrm>
           <a:prstGeom prst="rect">
             <a:avLst/>
@@ -13920,7 +14616,7 @@
         </p:spPr>
         <p:txBody>
           <a:bodyPr lIns="91440" tIns="45720" rIns="91440" bIns="45720" anchor="ctr">
-            <a:normAutofit fontScale="92500" lnSpcReduction="9999"/>
+            <a:normAutofit lnSpcReduction="9999"/>
           </a:bodyPr>
           <a:p>
             <a:pPr marL="285840" indent="-285840" algn="l" defTabSz="457200">
@@ -13955,7 +14651,7 @@
                 <a:latin typeface="Times New Roman"/>
                 <a:ea typeface="Arial"/>
               </a:rPr>
-              <a:t> Demonstrates real-time coordination tracking and collision detection within a terminal environment. </a:t>
+              <a:t> Showcases mathematical processing and "Shortest Distance" algorithms to determine a winner among multiple participants.</a:t>
             </a:r>
             <a:endParaRPr lang="en-US" sz="2400" b="0" u="none" strike="noStrike">
               <a:solidFill>
@@ -14012,24 +14708,14 @@
               <a:defRPr/>
             </a:pPr>
             <a:r>
-              <a:rPr lang="en-US" sz="2400" b="1" u="none" strike="noStrike">
+              <a:rPr lang="en-US" sz="2400" b="0" u="none" strike="noStrike">
                 <a:solidFill>
                   <a:schemeClr val="lt1"/>
                 </a:solidFill>
                 <a:latin typeface="Times New Roman"/>
                 <a:ea typeface="Arial"/>
               </a:rPr>
-              <a:t>curses.wrapper()</a:t>
-            </a:r>
-            <a:r>
-              <a:rPr lang="en-US" sz="2400" b="0" u="none" strike="noStrike">
-                <a:solidFill>
-                  <a:schemeClr val="lt1"/>
-                </a:solidFill>
-                <a:latin typeface="Times New Roman"/>
-                <a:ea typeface="Arial"/>
-              </a:rPr>
-              <a:t>: Switches the terminal into a "game window" that allows for colored graphics and exact positioning of characters. </a:t>
+              <a:t>random.randint(1, 100): Generates the secret target number on the Host machine.</a:t>
             </a:r>
             <a:endParaRPr lang="en-US" sz="2400" b="0" u="none" strike="noStrike">
               <a:solidFill>
@@ -14054,6 +14740,16 @@
               <a:defRPr/>
             </a:pPr>
             <a:r>
+              <a:rPr lang="en-US" sz="2400" b="0" u="none" strike="noStrike">
+                <a:solidFill>
+                  <a:schemeClr val="lt1"/>
+                </a:solidFill>
+                <a:latin typeface="Times New Roman"/>
+                <a:ea typeface="Arial"/>
+              </a:rPr>
+              <a:t>abs(target - guess): The </a:t>
+            </a:r>
+            <a:r>
               <a:rPr lang="en-US" sz="2400" b="1" u="none" strike="noStrike">
                 <a:solidFill>
                   <a:schemeClr val="lt1"/>
@@ -14061,7 +14757,7 @@
                 <a:latin typeface="Times New Roman"/>
                 <a:ea typeface="Arial"/>
               </a:rPr>
-              <a:t>Coordinate Management</a:t>
+              <a:t>Absolute Value</a:t>
             </a:r>
             <a:r>
               <a:rPr lang="en-US" sz="2400" b="0" u="none" strike="noStrike">
@@ -14071,27 +14767,7 @@
                 <a:latin typeface="Times New Roman"/>
                 <a:ea typeface="Arial"/>
               </a:rPr>
-              <a:t>: Stores the snake's body as a </a:t>
-            </a:r>
-            <a:r>
-              <a:rPr lang="en-US" sz="2400" b="1" u="none" strike="noStrike">
-                <a:solidFill>
-                  <a:schemeClr val="lt1"/>
-                </a:solidFill>
-                <a:latin typeface="Times New Roman"/>
-                <a:ea typeface="Arial"/>
-              </a:rPr>
-              <a:t>list of (x, y) points</a:t>
-            </a:r>
-            <a:r>
-              <a:rPr lang="en-US" sz="2400" b="0" u="none" strike="noStrike">
-                <a:solidFill>
-                  <a:schemeClr val="lt1"/>
-                </a:solidFill>
-                <a:latin typeface="Times New Roman"/>
-                <a:ea typeface="Arial"/>
-              </a:rPr>
-              <a:t> to track every segment on the 28 X 14 grid. </a:t>
+              <a:t> function calculates how far each player is from the target, regardless of whether they guessed too high or too low.</a:t>
             </a:r>
             <a:endParaRPr lang="en-US" sz="2400" b="0" u="none" strike="noStrike">
               <a:solidFill>
@@ -14116,128 +14792,14 @@
               <a:defRPr/>
             </a:pPr>
             <a:r>
-              <a:rPr lang="en-US" sz="2400" b="1" u="none" strike="noStrike">
+              <a:rPr lang="en-US" sz="2400" b="0" u="none" strike="noStrike">
                 <a:solidFill>
                   <a:schemeClr val="lt1"/>
                 </a:solidFill>
                 <a:latin typeface="Times New Roman"/>
                 <a:ea typeface="Arial"/>
               </a:rPr>
-              <a:t>_is_wall()</a:t>
-            </a:r>
-            <a:r>
-              <a:rPr lang="en-US" sz="2400" b="0" u="none" strike="noStrike">
-                <a:solidFill>
-                  <a:schemeClr val="lt1"/>
-                </a:solidFill>
-                <a:latin typeface="Times New Roman"/>
-                <a:ea typeface="Arial"/>
-              </a:rPr>
-              <a:t>: A boundary check that ends the game instantly if the snake's head hits the edge of the grid. </a:t>
-            </a:r>
-            <a:endParaRPr lang="en-US" sz="2400" b="0" u="none" strike="noStrike">
-              <a:solidFill>
-                <a:schemeClr val="lt1"/>
-              </a:solidFill>
-              <a:latin typeface="Calibri"/>
-            </a:endParaRPr>
-          </a:p>
-          <a:p>
-            <a:pPr marL="285840" indent="-285840" algn="l" defTabSz="457200">
-              <a:lnSpc>
-                <a:spcPct val="100000"/>
-              </a:lnSpc>
-              <a:spcAft>
-                <a:spcPts val="1001"/>
-              </a:spcAft>
-              <a:buClr>
-                <a:srgbClr val="FFFFFF"/>
-              </a:buClr>
-              <a:buFont typeface="Arial"/>
-              <a:buChar char="•"/>
-              <a:defRPr/>
-            </a:pPr>
-            <a:r>
-              <a:rPr lang="en-US" sz="2400" b="1" u="none" strike="noStrike">
-                <a:solidFill>
-                  <a:schemeClr val="lt1"/>
-                </a:solidFill>
-                <a:latin typeface="Times New Roman"/>
-                <a:ea typeface="Arial"/>
-              </a:rPr>
-              <a:t>_spawn_apple()</a:t>
-            </a:r>
-            <a:r>
-              <a:rPr lang="en-US" sz="2400" b="0" u="none" strike="noStrike">
-                <a:solidFill>
-                  <a:schemeClr val="lt1"/>
-                </a:solidFill>
-                <a:latin typeface="Times New Roman"/>
-                <a:ea typeface="Arial"/>
-              </a:rPr>
-              <a:t>: scans for empty spaces to ensure new apples don't appear inside walls or the snake's body. </a:t>
-            </a:r>
-            <a:endParaRPr lang="en-US" sz="2400" b="0" u="none" strike="noStrike">
-              <a:solidFill>
-                <a:schemeClr val="lt1"/>
-              </a:solidFill>
-              <a:latin typeface="Calibri"/>
-            </a:endParaRPr>
-          </a:p>
-          <a:p>
-            <a:pPr marL="285840" indent="-285840" algn="l" defTabSz="457200">
-              <a:lnSpc>
-                <a:spcPct val="100000"/>
-              </a:lnSpc>
-              <a:spcAft>
-                <a:spcPts val="1001"/>
-              </a:spcAft>
-              <a:buClr>
-                <a:srgbClr val="FFFFFF"/>
-              </a:buClr>
-              <a:buFont typeface="Arial"/>
-              <a:buChar char="•"/>
-              <a:defRPr/>
-            </a:pPr>
-            <a:r>
-              <a:rPr lang="en-US" sz="2400" b="1" u="none" strike="noStrike">
-                <a:solidFill>
-                  <a:schemeClr val="lt1"/>
-                </a:solidFill>
-                <a:latin typeface="Times New Roman"/>
-                <a:ea typeface="Arial"/>
-              </a:rPr>
-              <a:t>stdscr.timeout()</a:t>
-            </a:r>
-            <a:r>
-              <a:rPr lang="en-US" sz="2400" b="0" u="none" strike="noStrike">
-                <a:solidFill>
-                  <a:schemeClr val="lt1"/>
-                </a:solidFill>
-                <a:latin typeface="Times New Roman"/>
-                <a:ea typeface="Arial"/>
-              </a:rPr>
-              <a:t>: Sets the </a:t>
-            </a:r>
-            <a:r>
-              <a:rPr lang="en-US" sz="2400" b="1" u="none" strike="noStrike">
-                <a:solidFill>
-                  <a:schemeClr val="lt1"/>
-                </a:solidFill>
-                <a:latin typeface="Times New Roman"/>
-                <a:ea typeface="Arial"/>
-              </a:rPr>
-              <a:t>game speed</a:t>
-            </a:r>
-            <a:r>
-              <a:rPr lang="en-US" sz="2400" b="0" u="none" strike="noStrike">
-                <a:solidFill>
-                  <a:schemeClr val="lt1"/>
-                </a:solidFill>
-                <a:latin typeface="Times New Roman"/>
-                <a:ea typeface="Arial"/>
-              </a:rPr>
-              <a:t> (0.12s), which determines how fast the snake moves and how often the screen refreshes. </a:t>
+              <a:t>min(): Applied to a list of player distances to identify the "closest" guess and declare the round winner.</a:t>
             </a:r>
             <a:endParaRPr lang="en-US" sz="2400" b="0" u="none" strike="noStrike">
               <a:solidFill>
@@ -14271,18 +14833,19 @@
       </p:sp>
       <p:pic>
         <p:nvPicPr>
-          <p:cNvPr id="1776994404" name="Picture 4" descr="A computer screen shot of a white rectangle&#10;&#10;Description automatically generated"/>
+          <p:cNvPr id="1823824592" name="Picture 4" descr="A purple and blue text&#10;&#10;Description automatically generated"/>
           <p:cNvPicPr/>
           <p:nvPr/>
         </p:nvPicPr>
         <p:blipFill rotWithShape="1">
           <a:blip r:embed="rId3"/>
+          <a:srcRect l="0" t="8172" r="0" b="5617"/>
           <a:stretch/>
         </p:blipFill>
         <p:spPr bwMode="auto">
           <a:xfrm>
-            <a:off x="6896160" y="2836440"/>
-            <a:ext cx="5282640" cy="2077920"/>
+            <a:off x="5759640" y="2917440"/>
+            <a:ext cx="6338160" cy="1044000"/>
           </a:xfrm>
           <a:prstGeom prst="rect">
             <a:avLst/>
@@ -14328,7 +14891,7 @@
       </p:grpSpPr>
       <p:sp>
         <p:nvSpPr>
-          <p:cNvPr id="76554000" name="PlaceHolder 1"/>
+          <p:cNvPr id="1360825104" name="PlaceHolder 1"/>
           <p:cNvSpPr>
             <a:spLocks noGrp="1"/>
           </p:cNvSpPr>
@@ -14338,7 +14901,7 @@
         </p:nvSpPr>
         <p:spPr bwMode="auto">
           <a:xfrm>
-            <a:off x="720360" y="-168480"/>
+            <a:off x="685800" y="-164160"/>
             <a:ext cx="10130760" cy="1455480"/>
           </a:xfrm>
           <a:prstGeom prst="rect">
@@ -14372,7 +14935,7 @@
                 <a:latin typeface="Times New Roman"/>
                 <a:ea typeface="Arial"/>
               </a:rPr>
-              <a:t>Game 5: Pacman chase</a:t>
+              <a:t>GAME 4: Snake </a:t>
             </a:r>
             <a:endParaRPr lang="en-US" sz="5400" b="0" u="none" strike="noStrike" cap="all">
               <a:solidFill>
@@ -14385,7 +14948,7 @@
       </p:sp>
       <p:sp>
         <p:nvSpPr>
-          <p:cNvPr id="1852156611" name="PlaceHolder 2"/>
+          <p:cNvPr id="128517395" name="PlaceHolder 2"/>
           <p:cNvSpPr>
             <a:spLocks noGrp="1"/>
           </p:cNvSpPr>
@@ -14395,8 +14958,8 @@
         </p:nvSpPr>
         <p:spPr bwMode="auto">
           <a:xfrm>
-            <a:off x="178560" y="1208520"/>
-            <a:ext cx="6611400" cy="5207760"/>
+            <a:off x="114480" y="1103400"/>
+            <a:ext cx="6920640" cy="5753880"/>
           </a:xfrm>
           <a:prstGeom prst="rect">
             <a:avLst/>
@@ -14408,7 +14971,7 @@
         </p:spPr>
         <p:txBody>
           <a:bodyPr lIns="91440" tIns="45720" rIns="91440" bIns="45720" anchor="ctr">
-            <a:noAutofit/>
+            <a:normAutofit fontScale="92500" lnSpcReduction="9999"/>
           </a:bodyPr>
           <a:p>
             <a:pPr marL="285840" indent="-285840" algn="l" defTabSz="457200">
@@ -14426,7 +14989,7 @@
               <a:defRPr/>
             </a:pPr>
             <a:r>
-              <a:rPr lang="en-US" sz="2000" b="1" u="none" strike="noStrike">
+              <a:rPr lang="en-US" sz="2400" b="1" u="none" strike="noStrike">
                 <a:solidFill>
                   <a:schemeClr val="lt1"/>
                 </a:solidFill>
@@ -14436,16 +14999,16 @@
               <a:t>Purpose:</a:t>
             </a:r>
             <a:r>
-              <a:rPr lang="en-US" sz="2000" b="0" u="none" strike="noStrike">
+              <a:rPr lang="en-US" sz="2400" b="0" u="none" strike="noStrike">
                 <a:solidFill>
                   <a:schemeClr val="lt1"/>
                 </a:solidFill>
                 <a:latin typeface="Times New Roman"/>
                 <a:ea typeface="Arial"/>
               </a:rPr>
-              <a:t> The technical centerpiece. It demonstrates real-time hardware interaction, collision detection, and automated enemy intelligence.</a:t>
-            </a:r>
-            <a:endParaRPr lang="en-US" sz="2000" b="0" u="none" strike="noStrike">
+              <a:t> Demonstrates real-time coordination tracking and collision detection within a terminal environment. </a:t>
+            </a:r>
+            <a:endParaRPr lang="en-US" sz="2400" b="0" u="none" strike="noStrike">
               <a:solidFill>
                 <a:schemeClr val="lt1"/>
               </a:solidFill>
@@ -14468,7 +15031,7 @@
               <a:defRPr/>
             </a:pPr>
             <a:r>
-              <a:rPr lang="en-US" sz="2000" b="1" u="none" strike="noStrike">
+              <a:rPr lang="en-US" sz="2400" b="1" u="none" strike="noStrike">
                 <a:solidFill>
                   <a:schemeClr val="lt1"/>
                 </a:solidFill>
@@ -14477,7 +15040,7 @@
               </a:rPr>
               <a:t>Python Functions &amp; Logic:</a:t>
             </a:r>
-            <a:endParaRPr lang="en-US" sz="2000" b="0" u="none" strike="noStrike">
+            <a:endParaRPr lang="en-US" sz="2400" b="0" u="none" strike="noStrike">
               <a:solidFill>
                 <a:schemeClr val="lt1"/>
               </a:solidFill>
@@ -14500,16 +15063,26 @@
               <a:defRPr/>
             </a:pPr>
             <a:r>
-              <a:rPr lang="en-US" sz="2000" b="0" u="none" strike="noStrike">
+              <a:rPr lang="en-US" sz="2400" b="1" u="none" strike="noStrike">
                 <a:solidFill>
                   <a:schemeClr val="lt1"/>
                 </a:solidFill>
                 <a:latin typeface="Times New Roman"/>
                 <a:ea typeface="Arial"/>
               </a:rPr>
-              <a:t>curses.initscr(): Initializes the terminal into "window mode" to allow for coordinate-based graphics rather than scrolling text.</a:t>
-            </a:r>
-            <a:endParaRPr lang="en-US" sz="2000" b="0" u="none" strike="noStrike">
+              <a:t>curses.wrapper()</a:t>
+            </a:r>
+            <a:r>
+              <a:rPr lang="en-US" sz="2400" b="0" u="none" strike="noStrike">
+                <a:solidFill>
+                  <a:schemeClr val="lt1"/>
+                </a:solidFill>
+                <a:latin typeface="Times New Roman"/>
+                <a:ea typeface="Arial"/>
+              </a:rPr>
+              <a:t>: Switches the terminal into a "game window" that allows for colored graphics and exact positioning of characters. </a:t>
+            </a:r>
+            <a:endParaRPr lang="en-US" sz="2400" b="0" u="none" strike="noStrike">
               <a:solidFill>
                 <a:schemeClr val="lt1"/>
               </a:solidFill>
@@ -14532,26 +15105,46 @@
               <a:defRPr/>
             </a:pPr>
             <a:r>
-              <a:rPr lang="en-US" sz="2000" b="1" u="none" strike="noStrike">
+              <a:rPr lang="en-US" sz="2400" b="1" u="none" strike="noStrike">
                 <a:solidFill>
                   <a:schemeClr val="lt1"/>
                 </a:solidFill>
                 <a:latin typeface="Times New Roman"/>
                 <a:ea typeface="Arial"/>
               </a:rPr>
-              <a:t>BFS Algorithm (Breadth-First Search):</a:t>
-            </a:r>
-            <a:r>
-              <a:rPr lang="en-US" sz="2000" b="0" u="none" strike="noStrike">
+              <a:t>Coordinate Management</a:t>
+            </a:r>
+            <a:r>
+              <a:rPr lang="en-US" sz="2400" b="0" u="none" strike="noStrike">
                 <a:solidFill>
                   <a:schemeClr val="lt1"/>
                 </a:solidFill>
                 <a:latin typeface="Times New Roman"/>
                 <a:ea typeface="Arial"/>
               </a:rPr>
-              <a:t> A custom function that calculates the shortest path from the ghost to the player's coordinates through the maze.</a:t>
-            </a:r>
-            <a:endParaRPr lang="en-US" sz="2000" b="0" u="none" strike="noStrike">
+              <a:t>: Stores the snake's body as a </a:t>
+            </a:r>
+            <a:r>
+              <a:rPr lang="en-US" sz="2400" b="1" u="none" strike="noStrike">
+                <a:solidFill>
+                  <a:schemeClr val="lt1"/>
+                </a:solidFill>
+                <a:latin typeface="Times New Roman"/>
+                <a:ea typeface="Arial"/>
+              </a:rPr>
+              <a:t>list of (x, y) points</a:t>
+            </a:r>
+            <a:r>
+              <a:rPr lang="en-US" sz="2400" b="0" u="none" strike="noStrike">
+                <a:solidFill>
+                  <a:schemeClr val="lt1"/>
+                </a:solidFill>
+                <a:latin typeface="Times New Roman"/>
+                <a:ea typeface="Arial"/>
+              </a:rPr>
+              <a:t> to track every segment on the 28 X 14 grid. </a:t>
+            </a:r>
+            <a:endParaRPr lang="en-US" sz="2400" b="0" u="none" strike="noStrike">
               <a:solidFill>
                 <a:schemeClr val="lt1"/>
               </a:solidFill>
@@ -14574,16 +15167,26 @@
               <a:defRPr/>
             </a:pPr>
             <a:r>
-              <a:rPr lang="en-US" sz="2000" b="0" u="none" strike="noStrike">
+              <a:rPr lang="en-US" sz="2400" b="1" u="none" strike="noStrike">
                 <a:solidFill>
                   <a:schemeClr val="lt1"/>
                 </a:solidFill>
                 <a:latin typeface="Times New Roman"/>
                 <a:ea typeface="Arial"/>
               </a:rPr>
-              <a:t>stdscr.nodelay(True): Sets the terminal to "non-blocking" mode, allowing the game loop (and ghosts) to keep moving even if no key is pressed.</a:t>
-            </a:r>
-            <a:endParaRPr lang="en-US" sz="2000" b="0" u="none" strike="noStrike">
+              <a:t>_is_wall()</a:t>
+            </a:r>
+            <a:r>
+              <a:rPr lang="en-US" sz="2400" b="0" u="none" strike="noStrike">
+                <a:solidFill>
+                  <a:schemeClr val="lt1"/>
+                </a:solidFill>
+                <a:latin typeface="Times New Roman"/>
+                <a:ea typeface="Arial"/>
+              </a:rPr>
+              <a:t>: A boundary check that ends the game instantly if the snake's head hits the edge of the grid. </a:t>
+            </a:r>
+            <a:endParaRPr lang="en-US" sz="2400" b="0" u="none" strike="noStrike">
               <a:solidFill>
                 <a:schemeClr val="lt1"/>
               </a:solidFill>
@@ -14606,16 +15209,109 @@
               <a:defRPr/>
             </a:pPr>
             <a:r>
-              <a:rPr lang="en-US" sz="2000" b="0" u="none" strike="noStrike">
+              <a:rPr lang="en-US" sz="2400" b="1" u="none" strike="noStrike">
                 <a:solidFill>
                   <a:schemeClr val="lt1"/>
                 </a:solidFill>
                 <a:latin typeface="Times New Roman"/>
                 <a:ea typeface="Arial"/>
               </a:rPr>
-              <a:t>stdscr.getch(): Captures real-time keyboard hits (Arrow keys) to update the player's X and Y coordinates on the grid.</a:t>
-            </a:r>
-            <a:endParaRPr lang="en-US" sz="2000" b="0" u="none" strike="noStrike">
+              <a:t>_spawn_apple()</a:t>
+            </a:r>
+            <a:r>
+              <a:rPr lang="en-US" sz="2400" b="0" u="none" strike="noStrike">
+                <a:solidFill>
+                  <a:schemeClr val="lt1"/>
+                </a:solidFill>
+                <a:latin typeface="Times New Roman"/>
+                <a:ea typeface="Arial"/>
+              </a:rPr>
+              <a:t>: scans for empty spaces to ensure new apples don't appear inside walls or the snake's body. </a:t>
+            </a:r>
+            <a:endParaRPr lang="en-US" sz="2400" b="0" u="none" strike="noStrike">
+              <a:solidFill>
+                <a:schemeClr val="lt1"/>
+              </a:solidFill>
+              <a:latin typeface="Calibri"/>
+            </a:endParaRPr>
+          </a:p>
+          <a:p>
+            <a:pPr marL="285840" indent="-285840" algn="l" defTabSz="457200">
+              <a:lnSpc>
+                <a:spcPct val="100000"/>
+              </a:lnSpc>
+              <a:spcAft>
+                <a:spcPts val="1001"/>
+              </a:spcAft>
+              <a:buClr>
+                <a:srgbClr val="FFFFFF"/>
+              </a:buClr>
+              <a:buFont typeface="Arial"/>
+              <a:buChar char="•"/>
+              <a:defRPr/>
+            </a:pPr>
+            <a:r>
+              <a:rPr lang="en-US" sz="2400" b="1" u="none" strike="noStrike">
+                <a:solidFill>
+                  <a:schemeClr val="lt1"/>
+                </a:solidFill>
+                <a:latin typeface="Times New Roman"/>
+                <a:ea typeface="Arial"/>
+              </a:rPr>
+              <a:t>stdscr.timeout()</a:t>
+            </a:r>
+            <a:r>
+              <a:rPr lang="en-US" sz="2400" b="0" u="none" strike="noStrike">
+                <a:solidFill>
+                  <a:schemeClr val="lt1"/>
+                </a:solidFill>
+                <a:latin typeface="Times New Roman"/>
+                <a:ea typeface="Arial"/>
+              </a:rPr>
+              <a:t>: Sets the </a:t>
+            </a:r>
+            <a:r>
+              <a:rPr lang="en-US" sz="2400" b="1" u="none" strike="noStrike">
+                <a:solidFill>
+                  <a:schemeClr val="lt1"/>
+                </a:solidFill>
+                <a:latin typeface="Times New Roman"/>
+                <a:ea typeface="Arial"/>
+              </a:rPr>
+              <a:t>game speed</a:t>
+            </a:r>
+            <a:r>
+              <a:rPr lang="en-US" sz="2400" b="0" u="none" strike="noStrike">
+                <a:solidFill>
+                  <a:schemeClr val="lt1"/>
+                </a:solidFill>
+                <a:latin typeface="Times New Roman"/>
+                <a:ea typeface="Arial"/>
+              </a:rPr>
+              <a:t> (0.12s), which determines how fast the snake moves and how often the screen refreshes. </a:t>
+            </a:r>
+            <a:endParaRPr lang="en-US" sz="2400" b="0" u="none" strike="noStrike">
+              <a:solidFill>
+                <a:schemeClr val="lt1"/>
+              </a:solidFill>
+              <a:latin typeface="Calibri"/>
+            </a:endParaRPr>
+          </a:p>
+          <a:p>
+            <a:pPr indent="0" algn="l" defTabSz="457200">
+              <a:lnSpc>
+                <a:spcPct val="100000"/>
+              </a:lnSpc>
+              <a:spcAft>
+                <a:spcPts val="1001"/>
+              </a:spcAft>
+              <a:buNone/>
+              <a:tabLst>
+                <a:tab pos="0" algn="l"/>
+              </a:tabLst>
+              <a:defRPr/>
+            </a:pPr>
+            <a:endParaRPr lang="en-US" sz="1800" b="0" u="none" strike="noStrike">
               <a:solidFill>
                 <a:schemeClr val="lt1"/>
               </a:solidFill>
@@ -14626,7 +15322,7 @@
       </p:sp>
       <p:pic>
         <p:nvPicPr>
-          <p:cNvPr id="345460769" name="Picture 4" descr="A screenshot of a video game&#10;&#10;Description automatically generated"/>
+          <p:cNvPr id="827248463" name="Picture 4" descr="A computer screen shot of a white rectangle&#10;&#10;Description automatically generated"/>
           <p:cNvPicPr/>
           <p:nvPr/>
         </p:nvPicPr>
@@ -14636,8 +15332,8 @@
         </p:blipFill>
         <p:spPr bwMode="auto">
           <a:xfrm>
-            <a:off x="6946920" y="1287720"/>
-            <a:ext cx="4774320" cy="4662720"/>
+            <a:off x="6896160" y="2836440"/>
+            <a:ext cx="5282640" cy="2077920"/>
           </a:xfrm>
           <a:prstGeom prst="rect">
             <a:avLst/>
@@ -14683,7 +15379,64 @@
       </p:grpSpPr>
       <p:sp>
         <p:nvSpPr>
-          <p:cNvPr id="600278484" name="PlaceHolder 1"/>
+          <p:cNvPr id="113228586" name="PlaceHolder 1"/>
+          <p:cNvSpPr>
+            <a:spLocks noGrp="1"/>
+          </p:cNvSpPr>
+          <p:nvPr>
+            <p:ph type="title"/>
+          </p:nvPr>
+        </p:nvSpPr>
+        <p:spPr bwMode="auto">
+          <a:xfrm>
+            <a:off x="720360" y="-168480"/>
+            <a:ext cx="10130760" cy="1455480"/>
+          </a:xfrm>
+          <a:prstGeom prst="rect">
+            <a:avLst/>
+          </a:prstGeom>
+          <a:noFill/>
+          <a:ln w="0">
+            <a:noFill/>
+          </a:ln>
+        </p:spPr>
+        <p:txBody>
+          <a:bodyPr lIns="91440" tIns="45720" rIns="91440" bIns="45720" anchor="ctr">
+            <a:normAutofit/>
+          </a:bodyPr>
+          <a:p>
+            <a:pPr indent="0" algn="ctr" defTabSz="457200">
+              <a:lnSpc>
+                <a:spcPct val="100000"/>
+              </a:lnSpc>
+              <a:buNone/>
+              <a:tabLst>
+                <a:tab pos="0" algn="l"/>
+              </a:tabLst>
+              <a:defRPr/>
+            </a:pPr>
+            <a:r>
+              <a:rPr lang="en-US" sz="5400" b="1" u="none" strike="noStrike" cap="all">
+                <a:solidFill>
+                  <a:schemeClr val="lt1"/>
+                </a:solidFill>
+                <a:latin typeface="Times New Roman"/>
+                <a:ea typeface="Arial"/>
+              </a:rPr>
+              <a:t>Game 5: Pacman chase</a:t>
+            </a:r>
+            <a:endParaRPr lang="en-US" sz="5400" b="0" u="none" strike="noStrike" cap="all">
+              <a:solidFill>
+                <a:schemeClr val="lt1"/>
+              </a:solidFill>
+              <a:latin typeface="Calibri Light"/>
+            </a:endParaRPr>
+          </a:p>
+        </p:txBody>
+      </p:sp>
+      <p:sp>
+        <p:nvSpPr>
+          <p:cNvPr id="1525532764" name="PlaceHolder 2"/>
           <p:cNvSpPr>
             <a:spLocks noGrp="1"/>
           </p:cNvSpPr>
@@ -14693,8 +15446,8 @@
         </p:nvSpPr>
         <p:spPr bwMode="auto">
           <a:xfrm>
-            <a:off x="884879" y="-131760"/>
-            <a:ext cx="10130760" cy="1566720"/>
+            <a:off x="178560" y="1208520"/>
+            <a:ext cx="6611400" cy="5207760"/>
           </a:xfrm>
           <a:prstGeom prst="rect">
             <a:avLst/>
@@ -14706,191 +15459,225 @@
         </p:spPr>
         <p:txBody>
           <a:bodyPr lIns="91440" tIns="45720" rIns="91440" bIns="45720" anchor="ctr">
-            <a:normAutofit/>
+            <a:noAutofit/>
           </a:bodyPr>
           <a:p>
-            <a:pPr indent="0" algn="ctr" defTabSz="457200">
+            <a:pPr marL="285840" indent="-285840" algn="l" defTabSz="457200">
               <a:lnSpc>
                 <a:spcPct val="100000"/>
               </a:lnSpc>
               <a:spcAft>
                 <a:spcPts val="1001"/>
               </a:spcAft>
-              <a:buNone/>
-              <a:tabLst>
-                <a:tab pos="0" algn="l"/>
-              </a:tabLst>
-              <a:defRPr/>
-            </a:pPr>
-            <a:r>
-              <a:rPr lang="en-US" sz="5400" b="1" u="none" strike="noStrike">
+              <a:buClr>
+                <a:srgbClr val="FFFFFF"/>
+              </a:buClr>
+              <a:buFont typeface="Arial"/>
+              <a:buChar char="•"/>
+              <a:defRPr/>
+            </a:pPr>
+            <a:r>
+              <a:rPr lang="en-US" sz="2000" b="1" u="none" strike="noStrike">
                 <a:solidFill>
                   <a:schemeClr val="lt1"/>
                 </a:solidFill>
                 <a:latin typeface="Times New Roman"/>
                 <a:ea typeface="Arial"/>
               </a:rPr>
-              <a:t>How to Play</a:t>
-            </a:r>
-            <a:endParaRPr lang="en-US" sz="5400" b="0" u="none" strike="noStrike">
+              <a:t>Purpose:</a:t>
+            </a:r>
+            <a:r>
+              <a:rPr lang="en-US" sz="2000" b="0" u="none" strike="noStrike">
+                <a:solidFill>
+                  <a:schemeClr val="lt1"/>
+                </a:solidFill>
+                <a:latin typeface="Times New Roman"/>
+                <a:ea typeface="Arial"/>
+              </a:rPr>
+              <a:t> The technical centerpiece. It demonstrates real-time hardware interaction, collision detection, and automated enemy intelligence.</a:t>
+            </a:r>
+            <a:endParaRPr lang="en-US" sz="2000" b="0" u="none" strike="noStrike">
               <a:solidFill>
                 <a:schemeClr val="lt1"/>
               </a:solidFill>
               <a:latin typeface="Calibri"/>
             </a:endParaRPr>
           </a:p>
-        </p:txBody>
-      </p:sp>
-      <p:sp>
-        <p:nvSpPr>
-          <p:cNvPr id="505921372" name="TextBox 3"/>
-          <p:cNvSpPr/>
-          <p:nvPr/>
-        </p:nvSpPr>
-        <p:spPr bwMode="auto">
-          <a:xfrm>
-            <a:off x="1030320" y="1212480"/>
-            <a:ext cx="10144800" cy="2307600"/>
-          </a:xfrm>
-          <a:prstGeom prst="rect">
-            <a:avLst/>
-          </a:prstGeom>
-          <a:noFill/>
-          <a:ln w="0">
-            <a:noFill/>
-          </a:ln>
-        </p:spPr>
-        <p:style>
-          <a:lnRef idx="0"/>
-          <a:fillRef idx="0"/>
-          <a:effectRef idx="0"/>
-          <a:fontRef idx="minor"/>
-        </p:style>
-        <p:txBody>
-          <a:bodyPr lIns="90000" tIns="45000" rIns="90000" bIns="45000" anchor="t">
-            <a:spAutoFit/>
-          </a:bodyPr>
-          <a:p>
-            <a:pPr marL="343080" indent="-343080" defTabSz="457200">
-              <a:lnSpc>
-                <a:spcPct val="100000"/>
-              </a:lnSpc>
+          <a:p>
+            <a:pPr marL="285840" indent="-285840" algn="l" defTabSz="457200">
+              <a:lnSpc>
+                <a:spcPct val="100000"/>
+              </a:lnSpc>
+              <a:spcAft>
+                <a:spcPts val="1001"/>
+              </a:spcAft>
               <a:buClr>
                 <a:srgbClr val="FFFFFF"/>
               </a:buClr>
-              <a:buFont typeface="Calibri Light"/>
-              <a:buAutoNum type="arabicPeriod"/>
-              <a:defRPr/>
-            </a:pPr>
-            <a:r>
-              <a:rPr lang="en-US" sz="2400" b="0" u="none" strike="noStrike">
+              <a:buFont typeface="Arial"/>
+              <a:buChar char="•"/>
+              <a:defRPr/>
+            </a:pPr>
+            <a:r>
+              <a:rPr lang="en-US" sz="2000" b="1" u="none" strike="noStrike">
                 <a:solidFill>
                   <a:schemeClr val="lt1"/>
                 </a:solidFill>
                 <a:latin typeface="Times New Roman"/>
                 <a:ea typeface="Arial"/>
               </a:rPr>
-              <a:t>Ensure that all raspberry pis are on the same network and that python is installed on hardware</a:t>
-            </a:r>
-            <a:endParaRPr lang="en-US" sz="2400" b="0" u="none" strike="noStrike">
-              <a:solidFill>
-                <a:srgbClr val="FFFFFF"/>
-              </a:solidFill>
-              <a:latin typeface="Arial"/>
-            </a:endParaRPr>
-          </a:p>
-          <a:p>
-            <a:pPr marL="343080" indent="-343080" defTabSz="457200">
-              <a:lnSpc>
-                <a:spcPct val="100000"/>
-              </a:lnSpc>
+              <a:t>Python Functions &amp; Logic:</a:t>
+            </a:r>
+            <a:endParaRPr lang="en-US" sz="2000" b="0" u="none" strike="noStrike">
+              <a:solidFill>
+                <a:schemeClr val="lt1"/>
+              </a:solidFill>
+              <a:latin typeface="Calibri"/>
+            </a:endParaRPr>
+          </a:p>
+          <a:p>
+            <a:pPr marL="285840" indent="-285840" algn="l" defTabSz="457200">
+              <a:lnSpc>
+                <a:spcPct val="100000"/>
+              </a:lnSpc>
+              <a:spcAft>
+                <a:spcPts val="1001"/>
+              </a:spcAft>
               <a:buClr>
                 <a:srgbClr val="FFFFFF"/>
               </a:buClr>
-              <a:buFont typeface="Calibri Light"/>
-              <a:buAutoNum type="arabicPeriod"/>
-              <a:defRPr/>
-            </a:pPr>
-            <a:r>
-              <a:rPr lang="en-US" sz="2400" b="0" u="none" strike="noStrike">
+              <a:buFont typeface="Arial"/>
+              <a:buChar char="•"/>
+              <a:defRPr/>
+            </a:pPr>
+            <a:r>
+              <a:rPr lang="en-US" sz="2000" b="0" u="none" strike="noStrike">
                 <a:solidFill>
                   <a:schemeClr val="lt1"/>
                 </a:solidFill>
                 <a:latin typeface="Times New Roman"/>
                 <a:ea typeface="Arial"/>
               </a:rPr>
-              <a:t> Launch the game (host): open the terminal and navigate to the game folder</a:t>
-            </a:r>
-            <a:endParaRPr lang="en-US" sz="2400" b="0" u="none" strike="noStrike">
-              <a:solidFill>
-                <a:srgbClr val="FFFFFF"/>
-              </a:solidFill>
-              <a:latin typeface="Arial"/>
-            </a:endParaRPr>
-          </a:p>
-          <a:p>
-            <a:pPr marL="343080" indent="-343080" defTabSz="457200">
-              <a:lnSpc>
-                <a:spcPct val="100000"/>
-              </a:lnSpc>
+              <a:t>curses.initscr(): Initializes the terminal into "window mode" to allow for coordinate-based graphics rather than scrolling text.</a:t>
+            </a:r>
+            <a:endParaRPr lang="en-US" sz="2000" b="0" u="none" strike="noStrike">
+              <a:solidFill>
+                <a:schemeClr val="lt1"/>
+              </a:solidFill>
+              <a:latin typeface="Calibri"/>
+            </a:endParaRPr>
+          </a:p>
+          <a:p>
+            <a:pPr marL="285840" indent="-285840" algn="l" defTabSz="457200">
+              <a:lnSpc>
+                <a:spcPct val="100000"/>
+              </a:lnSpc>
+              <a:spcAft>
+                <a:spcPts val="1001"/>
+              </a:spcAft>
               <a:buClr>
                 <a:srgbClr val="FFFFFF"/>
               </a:buClr>
-              <a:buFont typeface="Calibri Light"/>
-              <a:buAutoNum type="arabicPeriod"/>
-              <a:defRPr/>
-            </a:pPr>
-            <a:r>
-              <a:rPr lang="en-US" sz="2400" b="0" u="none" strike="noStrike">
+              <a:buFont typeface="Arial"/>
+              <a:buChar char="•"/>
+              <a:defRPr/>
+            </a:pPr>
+            <a:r>
+              <a:rPr lang="en-US" sz="2000" b="1" u="none" strike="noStrike">
                 <a:solidFill>
                   <a:schemeClr val="lt1"/>
                 </a:solidFill>
                 <a:latin typeface="Times New Roman"/>
                 <a:ea typeface="Arial"/>
               </a:rPr>
-              <a:t> launch the game (player): open the terminal and navigate to the game folder. When prompted type the host’s IP address to join the game.</a:t>
-            </a:r>
-            <a:endParaRPr lang="en-US" sz="2400" b="0" u="none" strike="noStrike">
-              <a:solidFill>
-                <a:srgbClr val="FFFFFF"/>
-              </a:solidFill>
-              <a:latin typeface="Arial"/>
-            </a:endParaRPr>
-          </a:p>
-          <a:p>
-            <a:pPr marL="343080" indent="-343080" defTabSz="457200">
-              <a:lnSpc>
-                <a:spcPct val="100000"/>
-              </a:lnSpc>
+              <a:t>BFS Algorithm (Breadth-First Search):</a:t>
+            </a:r>
+            <a:r>
+              <a:rPr lang="en-US" sz="2000" b="0" u="none" strike="noStrike">
+                <a:solidFill>
+                  <a:schemeClr val="lt1"/>
+                </a:solidFill>
+                <a:latin typeface="Times New Roman"/>
+                <a:ea typeface="Arial"/>
+              </a:rPr>
+              <a:t> A custom function that calculates the shortest path from the ghost to the player's coordinates through the maze.</a:t>
+            </a:r>
+            <a:endParaRPr lang="en-US" sz="2000" b="0" u="none" strike="noStrike">
+              <a:solidFill>
+                <a:schemeClr val="lt1"/>
+              </a:solidFill>
+              <a:latin typeface="Calibri"/>
+            </a:endParaRPr>
+          </a:p>
+          <a:p>
+            <a:pPr marL="285840" indent="-285840" algn="l" defTabSz="457200">
+              <a:lnSpc>
+                <a:spcPct val="100000"/>
+              </a:lnSpc>
+              <a:spcAft>
+                <a:spcPts val="1001"/>
+              </a:spcAft>
               <a:buClr>
                 <a:srgbClr val="FFFFFF"/>
               </a:buClr>
-              <a:buFont typeface="Calibri Light"/>
-              <a:buAutoNum type="arabicPeriod"/>
-              <a:defRPr/>
-            </a:pPr>
-            <a:r>
-              <a:rPr lang="en-US" sz="2400" b="0" u="none" strike="noStrike">
+              <a:buFont typeface="Arial"/>
+              <a:buChar char="•"/>
+              <a:defRPr/>
+            </a:pPr>
+            <a:r>
+              <a:rPr lang="en-US" sz="2000" b="0" u="none" strike="noStrike">
                 <a:solidFill>
                   <a:schemeClr val="lt1"/>
                 </a:solidFill>
                 <a:latin typeface="Times New Roman"/>
                 <a:ea typeface="Arial"/>
               </a:rPr>
-              <a:t> </a:t>
-            </a:r>
-            <a:endParaRPr lang="en-US" sz="2400" b="0" u="none" strike="noStrike">
-              <a:solidFill>
-                <a:srgbClr val="FFFFFF"/>
-              </a:solidFill>
-              <a:latin typeface="Arial"/>
+              <a:t>stdscr.nodelay(True): Sets the terminal to "non-blocking" mode, allowing the game loop (and ghosts) to keep moving even if no key is pressed.</a:t>
+            </a:r>
+            <a:endParaRPr lang="en-US" sz="2000" b="0" u="none" strike="noStrike">
+              <a:solidFill>
+                <a:schemeClr val="lt1"/>
+              </a:solidFill>
+              <a:latin typeface="Calibri"/>
+            </a:endParaRPr>
+          </a:p>
+          <a:p>
+            <a:pPr marL="285840" indent="-285840" algn="l" defTabSz="457200">
+              <a:lnSpc>
+                <a:spcPct val="100000"/>
+              </a:lnSpc>
+              <a:spcAft>
+                <a:spcPts val="1001"/>
+              </a:spcAft>
+              <a:buClr>
+                <a:srgbClr val="FFFFFF"/>
+              </a:buClr>
+              <a:buFont typeface="Arial"/>
+              <a:buChar char="•"/>
+              <a:defRPr/>
+            </a:pPr>
+            <a:r>
+              <a:rPr lang="en-US" sz="2000" b="0" u="none" strike="noStrike">
+                <a:solidFill>
+                  <a:schemeClr val="lt1"/>
+                </a:solidFill>
+                <a:latin typeface="Times New Roman"/>
+                <a:ea typeface="Arial"/>
+              </a:rPr>
+              <a:t>stdscr.getch(): Captures real-time keyboard hits (Arrow keys) to update the player's X and Y coordinates on the grid.</a:t>
+            </a:r>
+            <a:endParaRPr lang="en-US" sz="2000" b="0" u="none" strike="noStrike">
+              <a:solidFill>
+                <a:schemeClr val="lt1"/>
+              </a:solidFill>
+              <a:latin typeface="Calibri"/>
             </a:endParaRPr>
           </a:p>
         </p:txBody>
       </p:sp>
       <p:pic>
         <p:nvPicPr>
-          <p:cNvPr id="170739153" name="Picture 5" descr="A screenshot of a computer&#10;&#10;Description automatically generated"/>
+          <p:cNvPr id="854046416" name="Picture 4" descr="A screenshot of a video game&#10;&#10;Description automatically generated"/>
           <p:cNvPicPr/>
           <p:nvPr/>
         </p:nvPicPr>
@@ -14900,8 +15687,8 @@
         </p:blipFill>
         <p:spPr bwMode="auto">
           <a:xfrm>
-            <a:off x="1465200" y="3207600"/>
-            <a:ext cx="7771680" cy="1725120"/>
+            <a:off x="6946920" y="1287720"/>
+            <a:ext cx="4774320" cy="4662720"/>
           </a:xfrm>
           <a:prstGeom prst="rect">
             <a:avLst/>
@@ -14912,276 +15699,6 @@
           </a:ln>
         </p:spPr>
       </p:pic>
-      <p:sp>
-        <p:nvSpPr>
-          <p:cNvPr id="139857535" name="TextBox 6"/>
-          <p:cNvSpPr/>
-          <p:nvPr/>
-        </p:nvSpPr>
-        <p:spPr bwMode="auto">
-          <a:xfrm>
-            <a:off x="968760" y="4933440"/>
-            <a:ext cx="9525240" cy="460800"/>
-          </a:xfrm>
-          <a:prstGeom prst="rect">
-            <a:avLst/>
-          </a:prstGeom>
-          <a:noFill/>
-          <a:ln w="0">
-            <a:noFill/>
-          </a:ln>
-        </p:spPr>
-        <p:style>
-          <a:lnRef idx="0"/>
-          <a:fillRef idx="0"/>
-          <a:effectRef idx="0"/>
-          <a:fontRef idx="minor"/>
-        </p:style>
-        <p:txBody>
-          <a:bodyPr lIns="90000" tIns="45000" rIns="90000" bIns="45000" anchor="t">
-            <a:spAutoFit/>
-          </a:bodyPr>
-          <a:p>
-            <a:pPr defTabSz="457200">
-              <a:lnSpc>
-                <a:spcPct val="100000"/>
-              </a:lnSpc>
-              <a:defRPr/>
-            </a:pPr>
-            <a:r>
-              <a:rPr lang="en-US" sz="2400" b="0" u="none" strike="noStrike">
-                <a:solidFill>
-                  <a:schemeClr val="lt1"/>
-                </a:solidFill>
-                <a:latin typeface="Times New Roman"/>
-                <a:ea typeface="Arial"/>
-              </a:rPr>
-              <a:t>5. Let’s play!</a:t>
-            </a:r>
-            <a:endParaRPr lang="en-US" sz="2400" b="0" u="none" strike="noStrike">
-              <a:solidFill>
-                <a:srgbClr val="FFFFFF"/>
-              </a:solidFill>
-              <a:latin typeface="Arial"/>
-            </a:endParaRPr>
-          </a:p>
-        </p:txBody>
-      </p:sp>
-      <p:pic>
-        <p:nvPicPr>
-          <p:cNvPr id="1818178847" name="Picture 5" descr="A screenshot of a computer&#10;&#10;Description automatically generated"/>
-          <p:cNvPicPr/>
-          <p:nvPr/>
-        </p:nvPicPr>
-        <p:blipFill rotWithShape="1">
-          <a:blip r:embed="rId3"/>
-          <a:srcRect l="74536" t="81275" r="1751" b="3995"/>
-          <a:stretch/>
-        </p:blipFill>
-        <p:spPr bwMode="auto">
-          <a:xfrm>
-            <a:off x="1519920" y="4260600"/>
-            <a:ext cx="2514240" cy="253080"/>
-          </a:xfrm>
-          <a:prstGeom prst="rect">
-            <a:avLst/>
-          </a:prstGeom>
-          <a:noFill/>
-          <a:ln w="0">
-            <a:noFill/>
-          </a:ln>
-        </p:spPr>
-      </p:pic>
-      <p:pic>
-        <p:nvPicPr>
-          <p:cNvPr id="1281808964" name="Picture 1" descr="A screenshot of a computer&#10;&#10;Description automatically generated"/>
-          <p:cNvPicPr/>
-          <p:nvPr/>
-        </p:nvPicPr>
-        <p:blipFill rotWithShape="1">
-          <a:blip r:embed="rId3"/>
-          <a:srcRect l="74536" t="81275" r="1751" b="3995"/>
-          <a:stretch/>
-        </p:blipFill>
-        <p:spPr bwMode="auto">
-          <a:xfrm>
-            <a:off x="5704560" y="4273560"/>
-            <a:ext cx="2514240" cy="253080"/>
-          </a:xfrm>
-          <a:prstGeom prst="rect">
-            <a:avLst/>
-          </a:prstGeom>
-          <a:noFill/>
-          <a:ln w="0">
-            <a:noFill/>
-          </a:ln>
-        </p:spPr>
-      </p:pic>
-      <p:sp>
-        <p:nvSpPr>
-          <p:cNvPr id="653283201" name=""/>
-          <p:cNvSpPr/>
-          <p:nvPr/>
-        </p:nvSpPr>
-        <p:spPr bwMode="auto">
-          <a:xfrm>
-            <a:off x="5679000" y="4275000"/>
-            <a:ext cx="1407240" cy="373680"/>
-          </a:xfrm>
-          <a:prstGeom prst="rect">
-            <a:avLst/>
-          </a:prstGeom>
-          <a:noFill/>
-          <a:ln w="0">
-            <a:noFill/>
-          </a:ln>
-        </p:spPr>
-        <p:style>
-          <a:lnRef idx="0"/>
-          <a:fillRef idx="0"/>
-          <a:effectRef idx="0"/>
-          <a:fontRef idx="minor"/>
-        </p:style>
-        <p:txBody>
-          <a:bodyPr lIns="90000" tIns="45000" rIns="90000" bIns="45000" anchor="t">
-            <a:spAutoFit/>
-          </a:bodyPr>
-          <a:p>
-            <a:pPr>
-              <a:lnSpc>
-                <a:spcPct val="100000"/>
-              </a:lnSpc>
-              <a:defRPr/>
-            </a:pPr>
-            <a:r>
-              <a:rPr lang="en-US" sz="950" b="0" u="none" strike="noStrike">
-                <a:solidFill>
-                  <a:srgbClr val="FFFFFF"/>
-                </a:solidFill>
-                <a:latin typeface="Arial"/>
-              </a:rPr>
-              <a:t>Use </a:t>
-            </a:r>
-            <a:r>
-              <a:rPr lang="en-US" sz="950" b="1" u="none" strike="noStrike">
-                <a:solidFill>
-                  <a:srgbClr val="FFFFFF"/>
-                </a:solidFill>
-                <a:latin typeface="Arial"/>
-              </a:rPr>
-              <a:t>WASD</a:t>
-            </a:r>
-            <a:r>
-              <a:rPr lang="en-US" sz="950" b="0" u="none" strike="noStrike">
-                <a:solidFill>
-                  <a:srgbClr val="FFFFFF"/>
-                </a:solidFill>
-                <a:latin typeface="Arial"/>
-              </a:rPr>
-              <a:t> to move</a:t>
-            </a:r>
-            <a:endParaRPr lang="en-US" sz="950" b="0" u="none" strike="noStrike">
-              <a:solidFill>
-                <a:srgbClr val="FFFFFF"/>
-              </a:solidFill>
-              <a:latin typeface="Arial"/>
-            </a:endParaRPr>
-          </a:p>
-        </p:txBody>
-      </p:sp>
-      <p:sp>
-        <p:nvSpPr>
-          <p:cNvPr id="448037355" name=""/>
-          <p:cNvSpPr/>
-          <p:nvPr/>
-        </p:nvSpPr>
-        <p:spPr bwMode="auto">
-          <a:xfrm>
-            <a:off x="1483920" y="4275360"/>
-            <a:ext cx="2514240" cy="235080"/>
-          </a:xfrm>
-          <a:prstGeom prst="rect">
-            <a:avLst/>
-          </a:prstGeom>
-          <a:noFill/>
-          <a:ln w="0">
-            <a:noFill/>
-          </a:ln>
-        </p:spPr>
-        <p:style>
-          <a:lnRef idx="0"/>
-          <a:fillRef idx="0"/>
-          <a:effectRef idx="0"/>
-          <a:fontRef idx="minor"/>
-        </p:style>
-        <p:txBody>
-          <a:bodyPr lIns="90000" tIns="45000" rIns="90000" bIns="45000" anchor="t">
-            <a:spAutoFit/>
-          </a:bodyPr>
-          <a:p>
-            <a:pPr>
-              <a:lnSpc>
-                <a:spcPct val="100000"/>
-              </a:lnSpc>
-              <a:defRPr/>
-            </a:pPr>
-            <a:r>
-              <a:rPr lang="en-US" sz="950" b="0" u="none" strike="noStrike">
-                <a:solidFill>
-                  <a:srgbClr val="FFFFFF"/>
-                </a:solidFill>
-                <a:latin typeface="Arial"/>
-                <a:ea typeface="Noto Sans CJK SC"/>
-              </a:rPr>
-              <a:t> </a:t>
-            </a:r>
-            <a:r>
-              <a:rPr lang="en-US" sz="950" b="1" u="none" strike="noStrike">
-                <a:solidFill>
-                  <a:srgbClr val="FFFFFF"/>
-                </a:solidFill>
-                <a:latin typeface="Arial"/>
-                <a:ea typeface="Noto Sans CJK SC"/>
-              </a:rPr>
-              <a:t>PacMan Chase</a:t>
-            </a:r>
-            <a:r>
-              <a:rPr lang="en-US" sz="950" b="0" u="none" strike="noStrike">
-                <a:solidFill>
-                  <a:srgbClr val="FFFFFF"/>
-                </a:solidFill>
-                <a:latin typeface="Arial"/>
-                <a:ea typeface="Noto Sans CJK SC"/>
-              </a:rPr>
-              <a:t> </a:t>
-            </a:r>
-            <a:r>
-              <a:rPr lang="en-US" sz="950" b="0" u="none" strike="noStrike">
-                <a:solidFill>
-                  <a:srgbClr val="FFFFFF"/>
-                </a:solidFill>
-                <a:latin typeface="Arial"/>
-              </a:rPr>
-              <a:t>and the </a:t>
-            </a:r>
-            <a:r>
-              <a:rPr lang="en-US" sz="950" b="1" u="none" strike="noStrike">
-                <a:solidFill>
-                  <a:srgbClr val="FFFFFF"/>
-                </a:solidFill>
-                <a:latin typeface="Arial"/>
-              </a:rPr>
-              <a:t>Snake Game</a:t>
-            </a:r>
-            <a:endParaRPr lang="en-US" sz="950" b="0" u="none" strike="noStrike">
-              <a:solidFill>
-                <a:srgbClr val="FFFFFF"/>
-              </a:solidFill>
-              <a:latin typeface="Arial"/>
-            </a:endParaRPr>
-          </a:p>
-        </p:txBody>
-      </p:sp>
     </p:spTree>
   </p:cSld>
   <p:clrMapOvr>

</xml_diff>